<commit_message>
Finalize Turkish demo presentation
</commit_message>
<xml_diff>
--- a/examples/demo-presentation.pptx
+++ b/examples/demo-presentation.pptx
@@ -508,7 +508,7 @@
           <a:lstStyle/>
           <a:p>
             <a:r>
-              <a:t>Explain why a modular workflow is easier to debug and extend.</a:t>
+              <a:t>Modüler bir iş akışının hata ayıklamayı ve sistemi geliştirmeyi neden kolaylaştırdığını açıklayın.</a:t>
             </a:r>
           </a:p>
         </p:txBody>
@@ -578,7 +578,7 @@
           <a:lstStyle/>
           <a:p>
             <a:r>
-              <a:t>Emphasize the separation between capability definitions and execution flow.</a:t>
+              <a:t>Skill tanımları ile yürütme akışının birbirinden ayrılmasının önemini vurgulayın.</a:t>
             </a:r>
           </a:p>
         </p:txBody>
@@ -648,7 +648,7 @@
           <a:lstStyle/>
           <a:p>
             <a:r>
-              <a:t>Describe the JSON schema as an interface contract.</a:t>
+              <a:t>JSON Schema'nın sistem bileşenleri arasında bir veri sözleşmesi görevi gördüğünü açıklayın.</a:t>
             </a:r>
           </a:p>
         </p:txBody>
@@ -718,7 +718,7 @@
           <a:lstStyle/>
           <a:p>
             <a:r>
-              <a:t>The demo is intentionally API-free so the repository remains easy to test.</a:t>
+              <a:t>Deponun kolayca test edilebilmesi için demonun ücretli bir yapay zeka API'sine ihtiyaç duymadığını açıklayın.</a:t>
             </a:r>
           </a:p>
         </p:txBody>
@@ -788,7 +788,7 @@
           <a:lstStyle/>
           <a:p>
             <a:r>
-              <a:t>Mention that model quality varies and production systems should add retries and stronger validation.</a:t>
+              <a:t>Model çıktısının değişebileceğini ve doğrulama katmanının bu nedenle önemli olduğunu açıklayın.</a:t>
             </a:r>
           </a:p>
         </p:txBody>
@@ -858,7 +858,7 @@
           <a:lstStyle/>
           <a:p>
             <a:r>
-              <a:t>Be explicit that these adapters are roadmap items rather than completed v1 features.</a:t>
+              <a:t>Bu adaptörlerin tamamlanmış v1 özellikleri değil, sonraki geliştirme adımları olduğunu özellikle belirtin.</a:t>
             </a:r>
           </a:p>
         </p:txBody>
@@ -3932,21 +3932,20 @@
           <a:noFill/>
         </p:spPr>
         <p:txBody>
-          <a:bodyPr wrap="none">
+          <a:bodyPr wrap="square" lIns="27432" rIns="27432" tIns="18288" bIns="18288">
             <a:spAutoFit/>
           </a:bodyPr>
           <a:lstStyle/>
           <a:p>
-            <a:pPr>
-              <a:defRPr sz="3000" b="1">
+            <a:pPr algn="l"/>
+            <a:r>
+              <a:rPr sz="3000" b="1">
                 <a:solidFill>
                   <a:srgbClr val="F0F3F8"/>
                 </a:solidFill>
                 <a:latin typeface="Arial"/>
-              </a:defRPr>
-            </a:pPr>
-            <a:r>
-              <a:t>From Prompt to Presentation</a:t>
+              </a:rPr>
+              <a:t>Prompt'tan Sunuma</a:t>
             </a:r>
           </a:p>
         </p:txBody>
@@ -3968,21 +3967,20 @@
           <a:noFill/>
         </p:spPr>
         <p:txBody>
-          <a:bodyPr wrap="none">
+          <a:bodyPr wrap="square" lIns="27432" rIns="27432" tIns="18288" bIns="18288">
             <a:spAutoFit/>
           </a:bodyPr>
           <a:lstStyle/>
           <a:p>
-            <a:pPr>
-              <a:defRPr sz="1600" b="0">
+            <a:pPr algn="l"/>
+            <a:r>
+              <a:rPr sz="1800" b="0">
                 <a:solidFill>
                   <a:srgbClr val="A3ABB8"/>
                 </a:solidFill>
                 <a:latin typeface="Arial"/>
-              </a:defRPr>
-            </a:pPr>
-            <a:r>
-              <a:t>A modular AI workflow for turning raw inputs into meeting-ready decks</a:t>
+              </a:rPr>
+              <a:t>Ham girdileri sunuma hazır çıktılara dönüştüren modüler yapay zeka iş akışı</a:t>
             </a:r>
           </a:p>
         </p:txBody>
@@ -3996,7 +3994,7 @@
         <p:spPr>
           <a:xfrm>
             <a:off x="987552" y="5349240"/>
-            <a:ext cx="5029200" cy="274320"/>
+            <a:ext cx="5943600" cy="320040"/>
           </a:xfrm>
           <a:prstGeom prst="rect">
             <a:avLst/>
@@ -4004,21 +4002,20 @@
           <a:noFill/>
         </p:spPr>
         <p:txBody>
-          <a:bodyPr wrap="none">
+          <a:bodyPr wrap="square" lIns="27432" rIns="27432" tIns="18288" bIns="18288">
             <a:spAutoFit/>
           </a:bodyPr>
           <a:lstStyle/>
           <a:p>
-            <a:pPr>
-              <a:defRPr sz="900" b="1">
+            <a:pPr algn="l"/>
+            <a:r>
+              <a:rPr sz="900" b="1">
                 <a:solidFill>
                   <a:srgbClr val="66F1BE"/>
                 </a:solidFill>
                 <a:latin typeface="Arial"/>
-              </a:defRPr>
-            </a:pPr>
-            <a:r>
-              <a:t>AI PRESENTATION AUTOMATION</a:t>
+              </a:rPr>
+              <a:t>YAPAY ZEKA DESTEKLİ SUNUM OTOMASYONU</a:t>
             </a:r>
           </a:p>
         </p:txBody>
@@ -4066,21 +4063,20 @@
           <a:noFill/>
         </p:spPr>
         <p:txBody>
-          <a:bodyPr wrap="none">
+          <a:bodyPr wrap="square" lIns="27432" rIns="27432" tIns="18288" bIns="18288">
             <a:spAutoFit/>
           </a:bodyPr>
           <a:lstStyle/>
           <a:p>
-            <a:pPr>
-              <a:defRPr sz="800" b="1">
+            <a:pPr algn="l"/>
+            <a:r>
+              <a:rPr sz="800" b="1">
                 <a:solidFill>
                   <a:srgbClr val="66F1BE"/>
                 </a:solidFill>
                 <a:latin typeface="Arial"/>
-              </a:defRPr>
-            </a:pPr>
-            <a:r>
-              <a:t>SLIDE 01</a:t>
+              </a:rPr>
+              <a:t>SLAYT 01</a:t>
             </a:r>
           </a:p>
         </p:txBody>
@@ -4094,7 +4090,7 @@
         <p:spPr>
           <a:xfrm>
             <a:off x="685800" y="914400"/>
-            <a:ext cx="10607040" cy="822960"/>
+            <a:ext cx="10607040" cy="640080"/>
           </a:xfrm>
           <a:prstGeom prst="rect">
             <a:avLst/>
@@ -4102,21 +4098,20 @@
           <a:noFill/>
         </p:spPr>
         <p:txBody>
-          <a:bodyPr wrap="none">
+          <a:bodyPr wrap="square" lIns="27432" rIns="27432" tIns="18288" bIns="18288">
             <a:spAutoFit/>
           </a:bodyPr>
           <a:lstStyle/>
           <a:p>
-            <a:pPr>
-              <a:defRPr sz="2500" b="1">
+            <a:pPr algn="l"/>
+            <a:r>
+              <a:rPr sz="2500" b="1">
                 <a:solidFill>
                   <a:srgbClr val="F0F3F8"/>
                 </a:solidFill>
                 <a:latin typeface="Arial"/>
-              </a:defRPr>
-            </a:pPr>
-            <a:r>
-              <a:t>Presentation work is a pipeline, not a single prompt</a:t>
+              </a:rPr>
+              <a:t>Sunum üretimi tek bir prompt değil, bir iş akışıdır</a:t>
             </a:r>
           </a:p>
         </p:txBody>
@@ -4130,7 +4125,7 @@
         <p:spPr>
           <a:xfrm>
             <a:off x="713232" y="1783080"/>
-            <a:ext cx="9875520" cy="594360"/>
+            <a:ext cx="10515600" cy="685800"/>
           </a:xfrm>
           <a:prstGeom prst="rect">
             <a:avLst/>
@@ -4138,21 +4133,20 @@
           <a:noFill/>
         </p:spPr>
         <p:txBody>
-          <a:bodyPr wrap="none">
+          <a:bodyPr wrap="square" lIns="27432" rIns="27432" tIns="18288" bIns="18288">
             <a:spAutoFit/>
           </a:bodyPr>
           <a:lstStyle/>
           <a:p>
-            <a:pPr>
-              <a:defRPr sz="1300" b="0">
+            <a:pPr algn="l"/>
+            <a:r>
+              <a:rPr sz="1300" b="0">
                 <a:solidFill>
                   <a:srgbClr val="A3ABB8"/>
                 </a:solidFill>
                 <a:latin typeface="Arial"/>
-              </a:defRPr>
-            </a:pPr>
-            <a:r>
-              <a:t>Separating research, narrative, QA and rendering makes the workflow easier to control.</a:t>
+              </a:rPr>
+              <a:t>Araştırma, anlatı, kalite güvencesi ve PPTX üretimini ayrı aşamalara bölmek iş akışını daha kontrol edilebilir hale getirir.</a:t>
             </a:r>
           </a:p>
         </p:txBody>
@@ -4166,7 +4160,7 @@
         <p:spPr>
           <a:xfrm>
             <a:off x="685800" y="2606040"/>
-            <a:ext cx="6995160" cy="3246120"/>
+            <a:ext cx="5806440" cy="3246120"/>
           </a:xfrm>
           <a:prstGeom prst="roundRect">
             <a:avLst/>
@@ -4210,8 +4204,8 @@
         </p:nvSpPr>
         <p:spPr>
           <a:xfrm>
-            <a:off x="987552" y="2907792"/>
-            <a:ext cx="274320" cy="320040"/>
+            <a:off x="960120" y="2907792"/>
+            <a:ext cx="228600" cy="274320"/>
           </a:xfrm>
           <a:prstGeom prst="rect">
             <a:avLst/>
@@ -4219,20 +4213,19 @@
           <a:noFill/>
         </p:spPr>
         <p:txBody>
-          <a:bodyPr wrap="none">
+          <a:bodyPr wrap="square" lIns="27432" rIns="27432" tIns="18288" bIns="18288">
             <a:spAutoFit/>
           </a:bodyPr>
           <a:lstStyle/>
           <a:p>
-            <a:pPr>
-              <a:defRPr sz="1400" b="1">
+            <a:pPr algn="l"/>
+            <a:r>
+              <a:rPr sz="1500" b="1">
                 <a:solidFill>
                   <a:srgbClr val="66F1BE"/>
                 </a:solidFill>
                 <a:latin typeface="Arial"/>
-              </a:defRPr>
-            </a:pPr>
-            <a:r>
+              </a:rPr>
               <a:t>•</a:t>
             </a:r>
           </a:p>
@@ -4246,8 +4239,8 @@
         </p:nvSpPr>
         <p:spPr>
           <a:xfrm>
-            <a:off x="1298448" y="2889504"/>
-            <a:ext cx="5897880" cy="502920"/>
+            <a:off x="1261872" y="2898648"/>
+            <a:ext cx="4800600" cy="438912"/>
           </a:xfrm>
           <a:prstGeom prst="rect">
             <a:avLst/>
@@ -4255,21 +4248,20 @@
           <a:noFill/>
         </p:spPr>
         <p:txBody>
-          <a:bodyPr wrap="none">
+          <a:bodyPr wrap="square" lIns="27432" rIns="27432" tIns="18288" bIns="18288">
             <a:spAutoFit/>
           </a:bodyPr>
           <a:lstStyle/>
           <a:p>
-            <a:pPr>
-              <a:defRPr sz="1400" b="0">
+            <a:pPr algn="l"/>
+            <a:r>
+              <a:rPr sz="1200" b="0">
                 <a:solidFill>
                   <a:srgbClr val="F0F3F8"/>
                 </a:solidFill>
                 <a:latin typeface="Arial"/>
-              </a:defRPr>
-            </a:pPr>
-            <a:r>
-              <a:t>Inputs can come from topics, notes or documents</a:t>
+              </a:rPr>
+              <a:t>Girdiler konu, not veya yapılandırılmış verilerden gelebilir</a:t>
             </a:r>
           </a:p>
         </p:txBody>
@@ -4282,8 +4274,8 @@
         </p:nvSpPr>
         <p:spPr>
           <a:xfrm>
-            <a:off x="987552" y="3438144"/>
-            <a:ext cx="274320" cy="320040"/>
+            <a:off x="960120" y="3438144"/>
+            <a:ext cx="228600" cy="274320"/>
           </a:xfrm>
           <a:prstGeom prst="rect">
             <a:avLst/>
@@ -4291,20 +4283,19 @@
           <a:noFill/>
         </p:spPr>
         <p:txBody>
-          <a:bodyPr wrap="none">
+          <a:bodyPr wrap="square" lIns="27432" rIns="27432" tIns="18288" bIns="18288">
             <a:spAutoFit/>
           </a:bodyPr>
           <a:lstStyle/>
           <a:p>
-            <a:pPr>
-              <a:defRPr sz="1400" b="1">
+            <a:pPr algn="l"/>
+            <a:r>
+              <a:rPr sz="1500" b="1">
                 <a:solidFill>
                   <a:srgbClr val="66F1BE"/>
                 </a:solidFill>
                 <a:latin typeface="Arial"/>
-              </a:defRPr>
-            </a:pPr>
-            <a:r>
+              </a:rPr>
               <a:t>•</a:t>
             </a:r>
           </a:p>
@@ -4318,8 +4309,8 @@
         </p:nvSpPr>
         <p:spPr>
           <a:xfrm>
-            <a:off x="1298448" y="3419856"/>
-            <a:ext cx="5897880" cy="502920"/>
+            <a:off x="1261872" y="3429000"/>
+            <a:ext cx="4800600" cy="438912"/>
           </a:xfrm>
           <a:prstGeom prst="rect">
             <a:avLst/>
@@ -4327,21 +4318,20 @@
           <a:noFill/>
         </p:spPr>
         <p:txBody>
-          <a:bodyPr wrap="none">
+          <a:bodyPr wrap="square" lIns="27432" rIns="27432" tIns="18288" bIns="18288">
             <a:spAutoFit/>
           </a:bodyPr>
           <a:lstStyle/>
           <a:p>
-            <a:pPr>
-              <a:defRPr sz="1400" b="0">
+            <a:pPr algn="l"/>
+            <a:r>
+              <a:rPr sz="1200" b="0">
                 <a:solidFill>
                   <a:srgbClr val="F0F3F8"/>
                 </a:solidFill>
                 <a:latin typeface="Arial"/>
-              </a:defRPr>
-            </a:pPr>
-            <a:r>
-              <a:t>AI produces structured presentation data</a:t>
+              </a:rPr>
+              <a:t>Yapay zeka yapılandırılmış sunum verisi üretir</a:t>
             </a:r>
           </a:p>
         </p:txBody>
@@ -4354,8 +4344,8 @@
         </p:nvSpPr>
         <p:spPr>
           <a:xfrm>
-            <a:off x="987552" y="3968496"/>
-            <a:ext cx="274320" cy="320040"/>
+            <a:off x="960120" y="3968496"/>
+            <a:ext cx="228600" cy="274320"/>
           </a:xfrm>
           <a:prstGeom prst="rect">
             <a:avLst/>
@@ -4363,20 +4353,19 @@
           <a:noFill/>
         </p:spPr>
         <p:txBody>
-          <a:bodyPr wrap="none">
+          <a:bodyPr wrap="square" lIns="27432" rIns="27432" tIns="18288" bIns="18288">
             <a:spAutoFit/>
           </a:bodyPr>
           <a:lstStyle/>
           <a:p>
-            <a:pPr>
-              <a:defRPr sz="1400" b="1">
+            <a:pPr algn="l"/>
+            <a:r>
+              <a:rPr sz="1500" b="1">
                 <a:solidFill>
                   <a:srgbClr val="66F1BE"/>
                 </a:solidFill>
                 <a:latin typeface="Arial"/>
-              </a:defRPr>
-            </a:pPr>
-            <a:r>
+              </a:rPr>
               <a:t>•</a:t>
             </a:r>
           </a:p>
@@ -4390,8 +4379,8 @@
         </p:nvSpPr>
         <p:spPr>
           <a:xfrm>
-            <a:off x="1298448" y="3950208"/>
-            <a:ext cx="5897880" cy="502920"/>
+            <a:off x="1261872" y="3959352"/>
+            <a:ext cx="4800600" cy="438912"/>
           </a:xfrm>
           <a:prstGeom prst="rect">
             <a:avLst/>
@@ -4399,21 +4388,20 @@
           <a:noFill/>
         </p:spPr>
         <p:txBody>
-          <a:bodyPr wrap="none">
+          <a:bodyPr wrap="square" lIns="27432" rIns="27432" tIns="18288" bIns="18288">
             <a:spAutoFit/>
           </a:bodyPr>
           <a:lstStyle/>
           <a:p>
-            <a:pPr>
-              <a:defRPr sz="1400" b="0">
+            <a:pPr algn="l"/>
+            <a:r>
+              <a:rPr sz="1200" b="0">
                 <a:solidFill>
                   <a:srgbClr val="F0F3F8"/>
                 </a:solidFill>
                 <a:latin typeface="Arial"/>
-              </a:defRPr>
-            </a:pPr>
-            <a:r>
-              <a:t>A deterministic renderer creates the PowerPoint</a:t>
+              </a:rPr>
+              <a:t>Deterministik PPTX motoru düzenlenebilir PowerPoint dosyasını oluşturur</a:t>
             </a:r>
           </a:p>
         </p:txBody>
@@ -4426,8 +4414,8 @@
         </p:nvSpPr>
         <p:spPr>
           <a:xfrm>
-            <a:off x="987552" y="4498848"/>
-            <a:ext cx="274320" cy="320040"/>
+            <a:off x="960120" y="4498848"/>
+            <a:ext cx="228600" cy="274320"/>
           </a:xfrm>
           <a:prstGeom prst="rect">
             <a:avLst/>
@@ -4435,20 +4423,19 @@
           <a:noFill/>
         </p:spPr>
         <p:txBody>
-          <a:bodyPr wrap="none">
+          <a:bodyPr wrap="square" lIns="27432" rIns="27432" tIns="18288" bIns="18288">
             <a:spAutoFit/>
           </a:bodyPr>
           <a:lstStyle/>
           <a:p>
-            <a:pPr>
-              <a:defRPr sz="1400" b="1">
+            <a:pPr algn="l"/>
+            <a:r>
+              <a:rPr sz="1500" b="1">
                 <a:solidFill>
                   <a:srgbClr val="66F1BE"/>
                 </a:solidFill>
                 <a:latin typeface="Arial"/>
-              </a:defRPr>
-            </a:pPr>
-            <a:r>
+              </a:rPr>
               <a:t>•</a:t>
             </a:r>
           </a:p>
@@ -4462,8 +4449,8 @@
         </p:nvSpPr>
         <p:spPr>
           <a:xfrm>
-            <a:off x="1298448" y="4480560"/>
-            <a:ext cx="5897880" cy="502920"/>
+            <a:off x="1261872" y="4489704"/>
+            <a:ext cx="4800600" cy="438912"/>
           </a:xfrm>
           <a:prstGeom prst="rect">
             <a:avLst/>
@@ -4471,21 +4458,20 @@
           <a:noFill/>
         </p:spPr>
         <p:txBody>
-          <a:bodyPr wrap="none">
+          <a:bodyPr wrap="square" lIns="27432" rIns="27432" tIns="18288" bIns="18288">
             <a:spAutoFit/>
           </a:bodyPr>
           <a:lstStyle/>
           <a:p>
-            <a:pPr>
-              <a:defRPr sz="1400" b="0">
+            <a:pPr algn="l"/>
+            <a:r>
+              <a:rPr sz="1200" b="0">
                 <a:solidFill>
                   <a:srgbClr val="F0F3F8"/>
                 </a:solidFill>
                 <a:latin typeface="Arial"/>
-              </a:defRPr>
-            </a:pPr>
-            <a:r>
-              <a:t>QA is isolated as its own review step</a:t>
+              </a:rPr>
+              <a:t>QA (Kalite Güvencesi) ayrı bir kontrol adımı olarak çalışır</a:t>
             </a:r>
           </a:p>
         </p:txBody>
@@ -4498,8 +4484,8 @@
         </p:nvSpPr>
         <p:spPr>
           <a:xfrm>
-            <a:off x="7955279" y="2606040"/>
-            <a:ext cx="3520440" cy="3246120"/>
+            <a:off x="6766560" y="2606040"/>
+            <a:ext cx="4709160" cy="3246120"/>
           </a:xfrm>
           <a:prstGeom prst="roundRect">
             <a:avLst/>
@@ -4543,8 +4529,8 @@
         </p:nvSpPr>
         <p:spPr>
           <a:xfrm>
-            <a:off x="8275320" y="2907792"/>
-            <a:ext cx="2468880" cy="274320"/>
+            <a:off x="7086600" y="2880360"/>
+            <a:ext cx="2743200" cy="228600"/>
           </a:xfrm>
           <a:prstGeom prst="rect">
             <a:avLst/>
@@ -4552,35 +4538,250 @@
           <a:noFill/>
         </p:spPr>
         <p:txBody>
-          <a:bodyPr wrap="none">
+          <a:bodyPr wrap="square" lIns="27432" rIns="27432" tIns="18288" bIns="18288">
             <a:spAutoFit/>
           </a:bodyPr>
           <a:lstStyle/>
           <a:p>
-            <a:pPr>
-              <a:defRPr sz="800" b="1">
+            <a:pPr algn="l"/>
+            <a:r>
+              <a:rPr sz="800" b="1">
                 <a:solidFill>
                   <a:srgbClr val="66F1BE"/>
                 </a:solidFill>
                 <a:latin typeface="Arial"/>
-              </a:defRPr>
-            </a:pPr>
-            <a:r>
-              <a:t>VISUAL DIRECTION</a:t>
-            </a:r>
-          </a:p>
-        </p:txBody>
-      </p:sp>
-      <p:sp>
-        <p:nvSpPr>
-          <p:cNvPr id="16" name="TextBox 15"/>
+              </a:rPr>
+              <a:t>MODÜLER SKILL KATMANI</a:t>
+            </a:r>
+          </a:p>
+        </p:txBody>
+      </p:sp>
+      <p:sp>
+        <p:nvSpPr>
+          <p:cNvPr id="16" name="Rounded Rectangle 15"/>
+          <p:cNvSpPr/>
+          <p:nvPr/>
+        </p:nvSpPr>
+        <p:spPr>
+          <a:xfrm>
+            <a:off x="7132320" y="3429000"/>
+            <a:ext cx="1645920" cy="685800"/>
+          </a:xfrm>
+          <a:prstGeom prst="roundRect">
+            <a:avLst/>
+          </a:prstGeom>
+          <a:solidFill>
+            <a:srgbClr val="161D28"/>
+          </a:solidFill>
+          <a:ln>
+            <a:solidFill>
+              <a:srgbClr val="262D39"/>
+            </a:solidFill>
+          </a:ln>
+        </p:spPr>
+        <p:style>
+          <a:lnRef idx="1">
+            <a:schemeClr val="accent1"/>
+          </a:lnRef>
+          <a:fillRef idx="3">
+            <a:schemeClr val="accent1"/>
+          </a:fillRef>
+          <a:effectRef idx="2">
+            <a:schemeClr val="accent1"/>
+          </a:effectRef>
+          <a:fontRef idx="minor">
+            <a:schemeClr val="lt1"/>
+          </a:fontRef>
+        </p:style>
+        <p:txBody>
+          <a:bodyPr rtlCol="0" anchor="ctr"/>
+          <a:lstStyle/>
+          <a:p>
+            <a:pPr algn="ctr"/>
+            <a:r>
+              <a:rPr sz="1100" b="1">
+                <a:solidFill>
+                  <a:srgbClr val="F0F3F8"/>
+                </a:solidFill>
+                <a:latin typeface="Arial"/>
+              </a:rPr>
+              <a:t>ARAŞTIRMA</a:t>
+            </a:r>
+          </a:p>
+        </p:txBody>
+      </p:sp>
+      <p:sp>
+        <p:nvSpPr>
+          <p:cNvPr id="17" name="Rounded Rectangle 16"/>
+          <p:cNvSpPr/>
+          <p:nvPr/>
+        </p:nvSpPr>
+        <p:spPr>
+          <a:xfrm>
+            <a:off x="9144000" y="3429000"/>
+            <a:ext cx="1645920" cy="685800"/>
+          </a:xfrm>
+          <a:prstGeom prst="roundRect">
+            <a:avLst/>
+          </a:prstGeom>
+          <a:solidFill>
+            <a:srgbClr val="161D28"/>
+          </a:solidFill>
+          <a:ln>
+            <a:solidFill>
+              <a:srgbClr val="262D39"/>
+            </a:solidFill>
+          </a:ln>
+        </p:spPr>
+        <p:style>
+          <a:lnRef idx="1">
+            <a:schemeClr val="accent1"/>
+          </a:lnRef>
+          <a:fillRef idx="3">
+            <a:schemeClr val="accent1"/>
+          </a:fillRef>
+          <a:effectRef idx="2">
+            <a:schemeClr val="accent1"/>
+          </a:effectRef>
+          <a:fontRef idx="minor">
+            <a:schemeClr val="lt1"/>
+          </a:fontRef>
+        </p:style>
+        <p:txBody>
+          <a:bodyPr rtlCol="0" anchor="ctr"/>
+          <a:lstStyle/>
+          <a:p>
+            <a:pPr algn="ctr"/>
+            <a:r>
+              <a:rPr sz="1100" b="1">
+                <a:solidFill>
+                  <a:srgbClr val="F0F3F8"/>
+                </a:solidFill>
+                <a:latin typeface="Arial"/>
+              </a:rPr>
+              <a:t>SUNUM</a:t>
+            </a:r>
+          </a:p>
+        </p:txBody>
+      </p:sp>
+      <p:sp>
+        <p:nvSpPr>
+          <p:cNvPr id="18" name="Rounded Rectangle 17"/>
+          <p:cNvSpPr/>
+          <p:nvPr/>
+        </p:nvSpPr>
+        <p:spPr>
+          <a:xfrm>
+            <a:off x="7132320" y="4434840"/>
+            <a:ext cx="1645920" cy="685800"/>
+          </a:xfrm>
+          <a:prstGeom prst="roundRect">
+            <a:avLst/>
+          </a:prstGeom>
+          <a:solidFill>
+            <a:srgbClr val="161D28"/>
+          </a:solidFill>
+          <a:ln>
+            <a:solidFill>
+              <a:srgbClr val="262D39"/>
+            </a:solidFill>
+          </a:ln>
+        </p:spPr>
+        <p:style>
+          <a:lnRef idx="1">
+            <a:schemeClr val="accent1"/>
+          </a:lnRef>
+          <a:fillRef idx="3">
+            <a:schemeClr val="accent1"/>
+          </a:fillRef>
+          <a:effectRef idx="2">
+            <a:schemeClr val="accent1"/>
+          </a:effectRef>
+          <a:fontRef idx="minor">
+            <a:schemeClr val="lt1"/>
+          </a:fontRef>
+        </p:style>
+        <p:txBody>
+          <a:bodyPr rtlCol="0" anchor="ctr"/>
+          <a:lstStyle/>
+          <a:p>
+            <a:pPr algn="ctr"/>
+            <a:r>
+              <a:rPr sz="1100" b="1">
+                <a:solidFill>
+                  <a:srgbClr val="F0F3F8"/>
+                </a:solidFill>
+                <a:latin typeface="Arial"/>
+              </a:rPr>
+              <a:t>DOKÜMAN</a:t>
+            </a:r>
+          </a:p>
+        </p:txBody>
+      </p:sp>
+      <p:sp>
+        <p:nvSpPr>
+          <p:cNvPr id="19" name="Rounded Rectangle 18"/>
+          <p:cNvSpPr/>
+          <p:nvPr/>
+        </p:nvSpPr>
+        <p:spPr>
+          <a:xfrm>
+            <a:off x="9144000" y="4434840"/>
+            <a:ext cx="1645920" cy="685800"/>
+          </a:xfrm>
+          <a:prstGeom prst="roundRect">
+            <a:avLst/>
+          </a:prstGeom>
+          <a:solidFill>
+            <a:srgbClr val="161D28"/>
+          </a:solidFill>
+          <a:ln>
+            <a:solidFill>
+              <a:srgbClr val="262D39"/>
+            </a:solidFill>
+          </a:ln>
+        </p:spPr>
+        <p:style>
+          <a:lnRef idx="1">
+            <a:schemeClr val="accent1"/>
+          </a:lnRef>
+          <a:fillRef idx="3">
+            <a:schemeClr val="accent1"/>
+          </a:fillRef>
+          <a:effectRef idx="2">
+            <a:schemeClr val="accent1"/>
+          </a:effectRef>
+          <a:fontRef idx="minor">
+            <a:schemeClr val="lt1"/>
+          </a:fontRef>
+        </p:style>
+        <p:txBody>
+          <a:bodyPr rtlCol="0" anchor="ctr"/>
+          <a:lstStyle/>
+          <a:p>
+            <a:pPr algn="ctr"/>
+            <a:r>
+              <a:rPr sz="1100" b="1">
+                <a:solidFill>
+                  <a:srgbClr val="F0F3F8"/>
+                </a:solidFill>
+                <a:latin typeface="Arial"/>
+              </a:rPr>
+              <a:t>QA</a:t>
+            </a:r>
+          </a:p>
+        </p:txBody>
+      </p:sp>
+      <p:sp>
+        <p:nvSpPr>
+          <p:cNvPr id="20" name="TextBox 19"/>
           <p:cNvSpPr txBox="1"/>
           <p:nvPr/>
         </p:nvSpPr>
         <p:spPr>
           <a:xfrm>
-            <a:off x="8275320" y="3383280"/>
-            <a:ext cx="2697480" cy="1508760"/>
+            <a:off x="7909560" y="5349240"/>
+            <a:ext cx="2468880" cy="274320"/>
           </a:xfrm>
           <a:prstGeom prst="rect">
             <a:avLst/>
@@ -4588,35 +4789,34 @@
           <a:noFill/>
         </p:spPr>
         <p:txBody>
-          <a:bodyPr wrap="none">
+          <a:bodyPr wrap="square" lIns="27432" rIns="27432" tIns="18288" bIns="18288">
             <a:spAutoFit/>
           </a:bodyPr>
           <a:lstStyle/>
           <a:p>
-            <a:pPr>
-              <a:defRPr sz="1400" b="0">
-                <a:solidFill>
-                  <a:srgbClr val="F0F3F8"/>
-                </a:solidFill>
-                <a:latin typeface="Arial"/>
-              </a:defRPr>
-            </a:pPr>
-            <a:r>
-              <a:t>Horizontal pipeline: Input → Skills → QA → JSON → PPTX</a:t>
-            </a:r>
-          </a:p>
-        </p:txBody>
-      </p:sp>
-      <p:sp>
-        <p:nvSpPr>
-          <p:cNvPr id="17" name="TextBox 16"/>
+            <a:pPr algn="ctr"/>
+            <a:r>
+              <a:rPr sz="900" b="1">
+                <a:solidFill>
+                  <a:srgbClr val="66F1BE"/>
+                </a:solidFill>
+                <a:latin typeface="Arial"/>
+              </a:rPr>
+              <a:t>ORKESTRASYON</a:t>
+            </a:r>
+          </a:p>
+        </p:txBody>
+      </p:sp>
+      <p:sp>
+        <p:nvSpPr>
+          <p:cNvPr id="21" name="TextBox 20"/>
           <p:cNvSpPr txBox="1"/>
           <p:nvPr/>
         </p:nvSpPr>
         <p:spPr>
           <a:xfrm>
             <a:off x="11155680" y="6446520"/>
-            <a:ext cx="548640" cy="228600"/>
+            <a:ext cx="502920" cy="182880"/>
           </a:xfrm>
           <a:prstGeom prst="rect">
             <a:avLst/>
@@ -4624,20 +4824,19 @@
           <a:noFill/>
         </p:spPr>
         <p:txBody>
-          <a:bodyPr wrap="none">
+          <a:bodyPr wrap="square" lIns="27432" rIns="27432" tIns="18288" bIns="18288">
             <a:spAutoFit/>
           </a:bodyPr>
           <a:lstStyle/>
           <a:p>
-            <a:pPr>
-              <a:defRPr sz="800" b="0">
+            <a:pPr algn="l"/>
+            <a:r>
+              <a:rPr sz="800" b="0">
                 <a:solidFill>
                   <a:srgbClr val="A3ABB8"/>
                 </a:solidFill>
                 <a:latin typeface="Arial"/>
-              </a:defRPr>
-            </a:pPr>
-            <a:r>
+              </a:rPr>
               <a:t>01</a:t>
             </a:r>
           </a:p>
@@ -4686,21 +4885,20 @@
           <a:noFill/>
         </p:spPr>
         <p:txBody>
-          <a:bodyPr wrap="none">
+          <a:bodyPr wrap="square" lIns="27432" rIns="27432" tIns="18288" bIns="18288">
             <a:spAutoFit/>
           </a:bodyPr>
           <a:lstStyle/>
           <a:p>
-            <a:pPr>
-              <a:defRPr sz="800" b="1">
+            <a:pPr algn="l"/>
+            <a:r>
+              <a:rPr sz="800" b="1">
                 <a:solidFill>
                   <a:srgbClr val="66F1BE"/>
                 </a:solidFill>
                 <a:latin typeface="Arial"/>
-              </a:defRPr>
-            </a:pPr>
-            <a:r>
-              <a:t>SLIDE 02</a:t>
+              </a:rPr>
+              <a:t>SLAYT 02</a:t>
             </a:r>
           </a:p>
         </p:txBody>
@@ -4714,7 +4912,7 @@
         <p:spPr>
           <a:xfrm>
             <a:off x="685800" y="914400"/>
-            <a:ext cx="10607040" cy="822960"/>
+            <a:ext cx="10607040" cy="640080"/>
           </a:xfrm>
           <a:prstGeom prst="rect">
             <a:avLst/>
@@ -4722,21 +4920,20 @@
           <a:noFill/>
         </p:spPr>
         <p:txBody>
-          <a:bodyPr wrap="none">
+          <a:bodyPr wrap="square" lIns="27432" rIns="27432" tIns="18288" bIns="18288">
             <a:spAutoFit/>
           </a:bodyPr>
           <a:lstStyle/>
           <a:p>
-            <a:pPr>
-              <a:defRPr sz="2500" b="1">
+            <a:pPr algn="l"/>
+            <a:r>
+              <a:rPr sz="2500" b="1">
                 <a:solidFill>
                   <a:srgbClr val="F0F3F8"/>
                 </a:solidFill>
                 <a:latin typeface="Arial"/>
-              </a:defRPr>
-            </a:pPr>
-            <a:r>
-              <a:t>Skills define behavior while workflows define order</a:t>
+              </a:rPr>
+              <a:t>Skill'ler görevleri, workflow'lar çalışma sırasını tanımlar</a:t>
             </a:r>
           </a:p>
         </p:txBody>
@@ -4750,7 +4947,7 @@
         <p:spPr>
           <a:xfrm>
             <a:off x="713232" y="1783080"/>
-            <a:ext cx="9875520" cy="594360"/>
+            <a:ext cx="10515600" cy="685800"/>
           </a:xfrm>
           <a:prstGeom prst="rect">
             <a:avLst/>
@@ -4758,21 +4955,20 @@
           <a:noFill/>
         </p:spPr>
         <p:txBody>
-          <a:bodyPr wrap="none">
+          <a:bodyPr wrap="square" lIns="27432" rIns="27432" tIns="18288" bIns="18288">
             <a:spAutoFit/>
           </a:bodyPr>
           <a:lstStyle/>
           <a:p>
-            <a:pPr>
-              <a:defRPr sz="1300" b="0">
+            <a:pPr algn="l"/>
+            <a:r>
+              <a:rPr sz="1300" b="0">
                 <a:solidFill>
                   <a:srgbClr val="A3ABB8"/>
                 </a:solidFill>
                 <a:latin typeface="Arial"/>
-              </a:defRPr>
-            </a:pPr>
-            <a:r>
-              <a:t>Reusable skills keep presentation quality rules independent from orchestration.</a:t>
+              </a:rPr>
+              <a:t>Yeniden kullanılabilir skill'ler sunum üretim kurallarını orkestrasyon mantığından bağımsız tutar.</a:t>
             </a:r>
           </a:p>
         </p:txBody>
@@ -4786,7 +4982,7 @@
         <p:spPr>
           <a:xfrm>
             <a:off x="685800" y="2606040"/>
-            <a:ext cx="6995160" cy="3246120"/>
+            <a:ext cx="5806440" cy="3246120"/>
           </a:xfrm>
           <a:prstGeom prst="roundRect">
             <a:avLst/>
@@ -4830,8 +5026,8 @@
         </p:nvSpPr>
         <p:spPr>
           <a:xfrm>
-            <a:off x="987552" y="2907792"/>
-            <a:ext cx="274320" cy="320040"/>
+            <a:off x="960120" y="2907792"/>
+            <a:ext cx="228600" cy="274320"/>
           </a:xfrm>
           <a:prstGeom prst="rect">
             <a:avLst/>
@@ -4839,20 +5035,19 @@
           <a:noFill/>
         </p:spPr>
         <p:txBody>
-          <a:bodyPr wrap="none">
+          <a:bodyPr wrap="square" lIns="27432" rIns="27432" tIns="18288" bIns="18288">
             <a:spAutoFit/>
           </a:bodyPr>
           <a:lstStyle/>
           <a:p>
-            <a:pPr>
-              <a:defRPr sz="1400" b="1">
+            <a:pPr algn="l"/>
+            <a:r>
+              <a:rPr sz="1500" b="1">
                 <a:solidFill>
                   <a:srgbClr val="66F1BE"/>
                 </a:solidFill>
                 <a:latin typeface="Arial"/>
-              </a:defRPr>
-            </a:pPr>
-            <a:r>
+              </a:rPr>
               <a:t>•</a:t>
             </a:r>
           </a:p>
@@ -4866,8 +5061,8 @@
         </p:nvSpPr>
         <p:spPr>
           <a:xfrm>
-            <a:off x="1298448" y="2889504"/>
-            <a:ext cx="5897880" cy="502920"/>
+            <a:off x="1261872" y="2898648"/>
+            <a:ext cx="4800600" cy="438912"/>
           </a:xfrm>
           <a:prstGeom prst="rect">
             <a:avLst/>
@@ -4875,21 +5070,20 @@
           <a:noFill/>
         </p:spPr>
         <p:txBody>
-          <a:bodyPr wrap="none">
+          <a:bodyPr wrap="square" lIns="27432" rIns="27432" tIns="18288" bIns="18288">
             <a:spAutoFit/>
           </a:bodyPr>
           <a:lstStyle/>
           <a:p>
-            <a:pPr>
-              <a:defRPr sz="1400" b="0">
+            <a:pPr algn="l"/>
+            <a:r>
+              <a:rPr sz="1200" b="0">
                 <a:solidFill>
                   <a:srgbClr val="F0F3F8"/>
                 </a:solidFill>
                 <a:latin typeface="Arial"/>
-              </a:defRPr>
-            </a:pPr>
-            <a:r>
-              <a:t>Research skill builds an evidence map</a:t>
+              </a:rPr>
+              <a:t>Araştırma Skill'i bir kanıt haritası oluşturur</a:t>
             </a:r>
           </a:p>
         </p:txBody>
@@ -4902,8 +5096,8 @@
         </p:nvSpPr>
         <p:spPr>
           <a:xfrm>
-            <a:off x="987552" y="3438144"/>
-            <a:ext cx="274320" cy="320040"/>
+            <a:off x="960120" y="3438144"/>
+            <a:ext cx="228600" cy="274320"/>
           </a:xfrm>
           <a:prstGeom prst="rect">
             <a:avLst/>
@@ -4911,20 +5105,19 @@
           <a:noFill/>
         </p:spPr>
         <p:txBody>
-          <a:bodyPr wrap="none">
+          <a:bodyPr wrap="square" lIns="27432" rIns="27432" tIns="18288" bIns="18288">
             <a:spAutoFit/>
           </a:bodyPr>
           <a:lstStyle/>
           <a:p>
-            <a:pPr>
-              <a:defRPr sz="1400" b="1">
+            <a:pPr algn="l"/>
+            <a:r>
+              <a:rPr sz="1500" b="1">
                 <a:solidFill>
                   <a:srgbClr val="66F1BE"/>
                 </a:solidFill>
                 <a:latin typeface="Arial"/>
-              </a:defRPr>
-            </a:pPr>
-            <a:r>
+              </a:rPr>
               <a:t>•</a:t>
             </a:r>
           </a:p>
@@ -4938,8 +5131,8 @@
         </p:nvSpPr>
         <p:spPr>
           <a:xfrm>
-            <a:off x="1298448" y="3419856"/>
-            <a:ext cx="5897880" cy="502920"/>
+            <a:off x="1261872" y="3429000"/>
+            <a:ext cx="4800600" cy="438912"/>
           </a:xfrm>
           <a:prstGeom prst="rect">
             <a:avLst/>
@@ -4947,21 +5140,20 @@
           <a:noFill/>
         </p:spPr>
         <p:txBody>
-          <a:bodyPr wrap="none">
+          <a:bodyPr wrap="square" lIns="27432" rIns="27432" tIns="18288" bIns="18288">
             <a:spAutoFit/>
           </a:bodyPr>
           <a:lstStyle/>
           <a:p>
-            <a:pPr>
-              <a:defRPr sz="1400" b="0">
+            <a:pPr algn="l"/>
+            <a:r>
+              <a:rPr sz="1200" b="0">
                 <a:solidFill>
                   <a:srgbClr val="F0F3F8"/>
                 </a:solidFill>
                 <a:latin typeface="Arial"/>
-              </a:defRPr>
-            </a:pPr>
-            <a:r>
-              <a:t>Presentation skill creates storyline and slides</a:t>
+              </a:rPr>
+              <a:t>Sunum Skill'i anlatı yapısını ve slaytları oluşturur</a:t>
             </a:r>
           </a:p>
         </p:txBody>
@@ -4974,8 +5166,8 @@
         </p:nvSpPr>
         <p:spPr>
           <a:xfrm>
-            <a:off x="987552" y="3968496"/>
-            <a:ext cx="274320" cy="320040"/>
+            <a:off x="960120" y="3968496"/>
+            <a:ext cx="228600" cy="274320"/>
           </a:xfrm>
           <a:prstGeom prst="rect">
             <a:avLst/>
@@ -4983,20 +5175,19 @@
           <a:noFill/>
         </p:spPr>
         <p:txBody>
-          <a:bodyPr wrap="none">
+          <a:bodyPr wrap="square" lIns="27432" rIns="27432" tIns="18288" bIns="18288">
             <a:spAutoFit/>
           </a:bodyPr>
           <a:lstStyle/>
           <a:p>
-            <a:pPr>
-              <a:defRPr sz="1400" b="1">
+            <a:pPr algn="l"/>
+            <a:r>
+              <a:rPr sz="1500" b="1">
                 <a:solidFill>
                   <a:srgbClr val="66F1BE"/>
                 </a:solidFill>
                 <a:latin typeface="Arial"/>
-              </a:defRPr>
-            </a:pPr>
-            <a:r>
+              </a:rPr>
               <a:t>•</a:t>
             </a:r>
           </a:p>
@@ -5010,8 +5201,8 @@
         </p:nvSpPr>
         <p:spPr>
           <a:xfrm>
-            <a:off x="1298448" y="3950208"/>
-            <a:ext cx="5897880" cy="502920"/>
+            <a:off x="1261872" y="3959352"/>
+            <a:ext cx="4800600" cy="438912"/>
           </a:xfrm>
           <a:prstGeom prst="rect">
             <a:avLst/>
@@ -5019,21 +5210,20 @@
           <a:noFill/>
         </p:spPr>
         <p:txBody>
-          <a:bodyPr wrap="none">
+          <a:bodyPr wrap="square" lIns="27432" rIns="27432" tIns="18288" bIns="18288">
             <a:spAutoFit/>
           </a:bodyPr>
           <a:lstStyle/>
           <a:p>
-            <a:pPr>
-              <a:defRPr sz="1400" b="0">
+            <a:pPr algn="l"/>
+            <a:r>
+              <a:rPr sz="1200" b="0">
                 <a:solidFill>
                   <a:srgbClr val="F0F3F8"/>
                 </a:solidFill>
                 <a:latin typeface="Arial"/>
-              </a:defRPr>
-            </a:pPr>
-            <a:r>
-              <a:t>Document skill compresses long-form material</a:t>
+              </a:rPr>
+              <a:t>Doküman Skill'i uzun içerikleri yapılandırılmış sunum girdisine dönüştürür</a:t>
             </a:r>
           </a:p>
         </p:txBody>
@@ -5046,8 +5236,8 @@
         </p:nvSpPr>
         <p:spPr>
           <a:xfrm>
-            <a:off x="987552" y="4498848"/>
-            <a:ext cx="274320" cy="320040"/>
+            <a:off x="960120" y="4498848"/>
+            <a:ext cx="228600" cy="274320"/>
           </a:xfrm>
           <a:prstGeom prst="rect">
             <a:avLst/>
@@ -5055,20 +5245,19 @@
           <a:noFill/>
         </p:spPr>
         <p:txBody>
-          <a:bodyPr wrap="none">
+          <a:bodyPr wrap="square" lIns="27432" rIns="27432" tIns="18288" bIns="18288">
             <a:spAutoFit/>
           </a:bodyPr>
           <a:lstStyle/>
           <a:p>
-            <a:pPr>
-              <a:defRPr sz="1400" b="1">
+            <a:pPr algn="l"/>
+            <a:r>
+              <a:rPr sz="1500" b="1">
                 <a:solidFill>
                   <a:srgbClr val="66F1BE"/>
                 </a:solidFill>
                 <a:latin typeface="Arial"/>
-              </a:defRPr>
-            </a:pPr>
-            <a:r>
+              </a:rPr>
               <a:t>•</a:t>
             </a:r>
           </a:p>
@@ -5082,8 +5271,8 @@
         </p:nvSpPr>
         <p:spPr>
           <a:xfrm>
-            <a:off x="1298448" y="4480560"/>
-            <a:ext cx="5897880" cy="502920"/>
+            <a:off x="1261872" y="4489704"/>
+            <a:ext cx="4800600" cy="438912"/>
           </a:xfrm>
           <a:prstGeom prst="rect">
             <a:avLst/>
@@ -5091,21 +5280,20 @@
           <a:noFill/>
         </p:spPr>
         <p:txBody>
-          <a:bodyPr wrap="none">
+          <a:bodyPr wrap="square" lIns="27432" rIns="27432" tIns="18288" bIns="18288">
             <a:spAutoFit/>
           </a:bodyPr>
           <a:lstStyle/>
           <a:p>
-            <a:pPr>
-              <a:defRPr sz="1400" b="0">
+            <a:pPr algn="l"/>
+            <a:r>
+              <a:rPr sz="1200" b="0">
                 <a:solidFill>
                   <a:srgbClr val="F0F3F8"/>
                 </a:solidFill>
                 <a:latin typeface="Arial"/>
-              </a:defRPr>
-            </a:pPr>
-            <a:r>
-              <a:t>QA skill detects structural and content problems</a:t>
+              </a:rPr>
+              <a:t>QA Skill'i yapısal ve içerik sorunlarını tespit eder</a:t>
             </a:r>
           </a:p>
         </p:txBody>
@@ -5118,8 +5306,8 @@
         </p:nvSpPr>
         <p:spPr>
           <a:xfrm>
-            <a:off x="7955279" y="2606040"/>
-            <a:ext cx="3520440" cy="3246120"/>
+            <a:off x="6766560" y="2606040"/>
+            <a:ext cx="4709160" cy="3246120"/>
           </a:xfrm>
           <a:prstGeom prst="roundRect">
             <a:avLst/>
@@ -5163,8 +5351,8 @@
         </p:nvSpPr>
         <p:spPr>
           <a:xfrm>
-            <a:off x="8275320" y="2907792"/>
-            <a:ext cx="2468880" cy="274320"/>
+            <a:off x="7086600" y="2880360"/>
+            <a:ext cx="2743200" cy="228600"/>
           </a:xfrm>
           <a:prstGeom prst="rect">
             <a:avLst/>
@@ -5172,35 +5360,250 @@
           <a:noFill/>
         </p:spPr>
         <p:txBody>
-          <a:bodyPr wrap="none">
+          <a:bodyPr wrap="square" lIns="27432" rIns="27432" tIns="18288" bIns="18288">
             <a:spAutoFit/>
           </a:bodyPr>
           <a:lstStyle/>
           <a:p>
-            <a:pPr>
-              <a:defRPr sz="800" b="1">
+            <a:pPr algn="l"/>
+            <a:r>
+              <a:rPr sz="800" b="1">
                 <a:solidFill>
                   <a:srgbClr val="66F1BE"/>
                 </a:solidFill>
                 <a:latin typeface="Arial"/>
-              </a:defRPr>
-            </a:pPr>
-            <a:r>
-              <a:t>VISUAL DIRECTION</a:t>
-            </a:r>
-          </a:p>
-        </p:txBody>
-      </p:sp>
-      <p:sp>
-        <p:nvSpPr>
-          <p:cNvPr id="16" name="TextBox 15"/>
+              </a:rPr>
+              <a:t>MODÜLER SKILL KATMANI</a:t>
+            </a:r>
+          </a:p>
+        </p:txBody>
+      </p:sp>
+      <p:sp>
+        <p:nvSpPr>
+          <p:cNvPr id="16" name="Rounded Rectangle 15"/>
+          <p:cNvSpPr/>
+          <p:nvPr/>
+        </p:nvSpPr>
+        <p:spPr>
+          <a:xfrm>
+            <a:off x="7132320" y="3429000"/>
+            <a:ext cx="1645920" cy="685800"/>
+          </a:xfrm>
+          <a:prstGeom prst="roundRect">
+            <a:avLst/>
+          </a:prstGeom>
+          <a:solidFill>
+            <a:srgbClr val="161D28"/>
+          </a:solidFill>
+          <a:ln>
+            <a:solidFill>
+              <a:srgbClr val="262D39"/>
+            </a:solidFill>
+          </a:ln>
+        </p:spPr>
+        <p:style>
+          <a:lnRef idx="1">
+            <a:schemeClr val="accent1"/>
+          </a:lnRef>
+          <a:fillRef idx="3">
+            <a:schemeClr val="accent1"/>
+          </a:fillRef>
+          <a:effectRef idx="2">
+            <a:schemeClr val="accent1"/>
+          </a:effectRef>
+          <a:fontRef idx="minor">
+            <a:schemeClr val="lt1"/>
+          </a:fontRef>
+        </p:style>
+        <p:txBody>
+          <a:bodyPr rtlCol="0" anchor="ctr"/>
+          <a:lstStyle/>
+          <a:p>
+            <a:pPr algn="ctr"/>
+            <a:r>
+              <a:rPr sz="1100" b="1">
+                <a:solidFill>
+                  <a:srgbClr val="F0F3F8"/>
+                </a:solidFill>
+                <a:latin typeface="Arial"/>
+              </a:rPr>
+              <a:t>ARAŞTIRMA</a:t>
+            </a:r>
+          </a:p>
+        </p:txBody>
+      </p:sp>
+      <p:sp>
+        <p:nvSpPr>
+          <p:cNvPr id="17" name="Rounded Rectangle 16"/>
+          <p:cNvSpPr/>
+          <p:nvPr/>
+        </p:nvSpPr>
+        <p:spPr>
+          <a:xfrm>
+            <a:off x="9144000" y="3429000"/>
+            <a:ext cx="1645920" cy="685800"/>
+          </a:xfrm>
+          <a:prstGeom prst="roundRect">
+            <a:avLst/>
+          </a:prstGeom>
+          <a:solidFill>
+            <a:srgbClr val="161D28"/>
+          </a:solidFill>
+          <a:ln>
+            <a:solidFill>
+              <a:srgbClr val="262D39"/>
+            </a:solidFill>
+          </a:ln>
+        </p:spPr>
+        <p:style>
+          <a:lnRef idx="1">
+            <a:schemeClr val="accent1"/>
+          </a:lnRef>
+          <a:fillRef idx="3">
+            <a:schemeClr val="accent1"/>
+          </a:fillRef>
+          <a:effectRef idx="2">
+            <a:schemeClr val="accent1"/>
+          </a:effectRef>
+          <a:fontRef idx="minor">
+            <a:schemeClr val="lt1"/>
+          </a:fontRef>
+        </p:style>
+        <p:txBody>
+          <a:bodyPr rtlCol="0" anchor="ctr"/>
+          <a:lstStyle/>
+          <a:p>
+            <a:pPr algn="ctr"/>
+            <a:r>
+              <a:rPr sz="1100" b="1">
+                <a:solidFill>
+                  <a:srgbClr val="F0F3F8"/>
+                </a:solidFill>
+                <a:latin typeface="Arial"/>
+              </a:rPr>
+              <a:t>SUNUM</a:t>
+            </a:r>
+          </a:p>
+        </p:txBody>
+      </p:sp>
+      <p:sp>
+        <p:nvSpPr>
+          <p:cNvPr id="18" name="Rounded Rectangle 17"/>
+          <p:cNvSpPr/>
+          <p:nvPr/>
+        </p:nvSpPr>
+        <p:spPr>
+          <a:xfrm>
+            <a:off x="7132320" y="4434840"/>
+            <a:ext cx="1645920" cy="685800"/>
+          </a:xfrm>
+          <a:prstGeom prst="roundRect">
+            <a:avLst/>
+          </a:prstGeom>
+          <a:solidFill>
+            <a:srgbClr val="161D28"/>
+          </a:solidFill>
+          <a:ln>
+            <a:solidFill>
+              <a:srgbClr val="262D39"/>
+            </a:solidFill>
+          </a:ln>
+        </p:spPr>
+        <p:style>
+          <a:lnRef idx="1">
+            <a:schemeClr val="accent1"/>
+          </a:lnRef>
+          <a:fillRef idx="3">
+            <a:schemeClr val="accent1"/>
+          </a:fillRef>
+          <a:effectRef idx="2">
+            <a:schemeClr val="accent1"/>
+          </a:effectRef>
+          <a:fontRef idx="minor">
+            <a:schemeClr val="lt1"/>
+          </a:fontRef>
+        </p:style>
+        <p:txBody>
+          <a:bodyPr rtlCol="0" anchor="ctr"/>
+          <a:lstStyle/>
+          <a:p>
+            <a:pPr algn="ctr"/>
+            <a:r>
+              <a:rPr sz="1100" b="1">
+                <a:solidFill>
+                  <a:srgbClr val="F0F3F8"/>
+                </a:solidFill>
+                <a:latin typeface="Arial"/>
+              </a:rPr>
+              <a:t>DOKÜMAN</a:t>
+            </a:r>
+          </a:p>
+        </p:txBody>
+      </p:sp>
+      <p:sp>
+        <p:nvSpPr>
+          <p:cNvPr id="19" name="Rounded Rectangle 18"/>
+          <p:cNvSpPr/>
+          <p:nvPr/>
+        </p:nvSpPr>
+        <p:spPr>
+          <a:xfrm>
+            <a:off x="9144000" y="4434840"/>
+            <a:ext cx="1645920" cy="685800"/>
+          </a:xfrm>
+          <a:prstGeom prst="roundRect">
+            <a:avLst/>
+          </a:prstGeom>
+          <a:solidFill>
+            <a:srgbClr val="161D28"/>
+          </a:solidFill>
+          <a:ln>
+            <a:solidFill>
+              <a:srgbClr val="262D39"/>
+            </a:solidFill>
+          </a:ln>
+        </p:spPr>
+        <p:style>
+          <a:lnRef idx="1">
+            <a:schemeClr val="accent1"/>
+          </a:lnRef>
+          <a:fillRef idx="3">
+            <a:schemeClr val="accent1"/>
+          </a:fillRef>
+          <a:effectRef idx="2">
+            <a:schemeClr val="accent1"/>
+          </a:effectRef>
+          <a:fontRef idx="minor">
+            <a:schemeClr val="lt1"/>
+          </a:fontRef>
+        </p:style>
+        <p:txBody>
+          <a:bodyPr rtlCol="0" anchor="ctr"/>
+          <a:lstStyle/>
+          <a:p>
+            <a:pPr algn="ctr"/>
+            <a:r>
+              <a:rPr sz="1100" b="1">
+                <a:solidFill>
+                  <a:srgbClr val="F0F3F8"/>
+                </a:solidFill>
+                <a:latin typeface="Arial"/>
+              </a:rPr>
+              <a:t>QA</a:t>
+            </a:r>
+          </a:p>
+        </p:txBody>
+      </p:sp>
+      <p:sp>
+        <p:nvSpPr>
+          <p:cNvPr id="20" name="TextBox 19"/>
           <p:cNvSpPr txBox="1"/>
           <p:nvPr/>
         </p:nvSpPr>
         <p:spPr>
           <a:xfrm>
-            <a:off x="8275320" y="3383280"/>
-            <a:ext cx="2697480" cy="1508760"/>
+            <a:off x="7909560" y="5349240"/>
+            <a:ext cx="2468880" cy="274320"/>
           </a:xfrm>
           <a:prstGeom prst="rect">
             <a:avLst/>
@@ -5208,35 +5611,34 @@
           <a:noFill/>
         </p:spPr>
         <p:txBody>
-          <a:bodyPr wrap="none">
+          <a:bodyPr wrap="square" lIns="27432" rIns="27432" tIns="18288" bIns="18288">
             <a:spAutoFit/>
           </a:bodyPr>
           <a:lstStyle/>
           <a:p>
-            <a:pPr>
-              <a:defRPr sz="1400" b="0">
-                <a:solidFill>
-                  <a:srgbClr val="F0F3F8"/>
-                </a:solidFill>
-                <a:latin typeface="Arial"/>
-              </a:defRPr>
-            </a:pPr>
-            <a:r>
-              <a:t>Four modular skill cards connected to an orchestration layer</a:t>
-            </a:r>
-          </a:p>
-        </p:txBody>
-      </p:sp>
-      <p:sp>
-        <p:nvSpPr>
-          <p:cNvPr id="17" name="TextBox 16"/>
+            <a:pPr algn="ctr"/>
+            <a:r>
+              <a:rPr sz="900" b="1">
+                <a:solidFill>
+                  <a:srgbClr val="66F1BE"/>
+                </a:solidFill>
+                <a:latin typeface="Arial"/>
+              </a:rPr>
+              <a:t>ORKESTRASYON</a:t>
+            </a:r>
+          </a:p>
+        </p:txBody>
+      </p:sp>
+      <p:sp>
+        <p:nvSpPr>
+          <p:cNvPr id="21" name="TextBox 20"/>
           <p:cNvSpPr txBox="1"/>
           <p:nvPr/>
         </p:nvSpPr>
         <p:spPr>
           <a:xfrm>
             <a:off x="11155680" y="6446520"/>
-            <a:ext cx="548640" cy="228600"/>
+            <a:ext cx="502920" cy="182880"/>
           </a:xfrm>
           <a:prstGeom prst="rect">
             <a:avLst/>
@@ -5244,20 +5646,19 @@
           <a:noFill/>
         </p:spPr>
         <p:txBody>
-          <a:bodyPr wrap="none">
+          <a:bodyPr wrap="square" lIns="27432" rIns="27432" tIns="18288" bIns="18288">
             <a:spAutoFit/>
           </a:bodyPr>
           <a:lstStyle/>
           <a:p>
-            <a:pPr>
-              <a:defRPr sz="800" b="0">
+            <a:pPr algn="l"/>
+            <a:r>
+              <a:rPr sz="800" b="0">
                 <a:solidFill>
                   <a:srgbClr val="A3ABB8"/>
                 </a:solidFill>
                 <a:latin typeface="Arial"/>
-              </a:defRPr>
-            </a:pPr>
-            <a:r>
+              </a:rPr>
               <a:t>02</a:t>
             </a:r>
           </a:p>
@@ -5306,21 +5707,20 @@
           <a:noFill/>
         </p:spPr>
         <p:txBody>
-          <a:bodyPr wrap="none">
+          <a:bodyPr wrap="square" lIns="27432" rIns="27432" tIns="18288" bIns="18288">
             <a:spAutoFit/>
           </a:bodyPr>
           <a:lstStyle/>
           <a:p>
-            <a:pPr>
-              <a:defRPr sz="800" b="1">
+            <a:pPr algn="l"/>
+            <a:r>
+              <a:rPr sz="800" b="1">
                 <a:solidFill>
                   <a:srgbClr val="66F1BE"/>
                 </a:solidFill>
                 <a:latin typeface="Arial"/>
-              </a:defRPr>
-            </a:pPr>
-            <a:r>
-              <a:t>SLIDE 03</a:t>
+              </a:rPr>
+              <a:t>SLAYT 03</a:t>
             </a:r>
           </a:p>
         </p:txBody>
@@ -5334,7 +5734,7 @@
         <p:spPr>
           <a:xfrm>
             <a:off x="685800" y="914400"/>
-            <a:ext cx="10607040" cy="822960"/>
+            <a:ext cx="10607040" cy="640080"/>
           </a:xfrm>
           <a:prstGeom prst="rect">
             <a:avLst/>
@@ -5342,21 +5742,20 @@
           <a:noFill/>
         </p:spPr>
         <p:txBody>
-          <a:bodyPr wrap="none">
+          <a:bodyPr wrap="square" lIns="27432" rIns="27432" tIns="18288" bIns="18288">
             <a:spAutoFit/>
           </a:bodyPr>
           <a:lstStyle/>
           <a:p>
-            <a:pPr>
-              <a:defRPr sz="2500" b="1">
+            <a:pPr algn="l"/>
+            <a:r>
+              <a:rPr sz="2500" b="1">
                 <a:solidFill>
                   <a:srgbClr val="F0F3F8"/>
                 </a:solidFill>
                 <a:latin typeface="Arial"/>
-              </a:defRPr>
-            </a:pPr>
-            <a:r>
-              <a:t>Structured JSON is the contract between AI and PowerPoint</a:t>
+              </a:rPr>
+              <a:t>Yapılandırılmış JSON, yapay zeka ile PowerPoint arasındaki sözleşmedir</a:t>
             </a:r>
           </a:p>
         </p:txBody>
@@ -5370,7 +5769,7 @@
         <p:spPr>
           <a:xfrm>
             <a:off x="713232" y="1783080"/>
-            <a:ext cx="9875520" cy="594360"/>
+            <a:ext cx="10515600" cy="685800"/>
           </a:xfrm>
           <a:prstGeom prst="rect">
             <a:avLst/>
@@ -5378,21 +5777,20 @@
           <a:noFill/>
         </p:spPr>
         <p:txBody>
-          <a:bodyPr wrap="none">
+          <a:bodyPr wrap="square" lIns="27432" rIns="27432" tIns="18288" bIns="18288">
             <a:spAutoFit/>
           </a:bodyPr>
           <a:lstStyle/>
           <a:p>
-            <a:pPr>
-              <a:defRPr sz="1300" b="0">
+            <a:pPr algn="l"/>
+            <a:r>
+              <a:rPr sz="1300" b="0">
                 <a:solidFill>
                   <a:srgbClr val="A3ABB8"/>
                 </a:solidFill>
                 <a:latin typeface="Arial"/>
-              </a:defRPr>
-            </a:pPr>
-            <a:r>
-              <a:t>The model does not directly manipulate slides; it produces validated structured data.</a:t>
+              </a:rPr>
+              <a:t>Model slaytları doğrudan değiştirmez; doğrulanabilir ve yapılandırılmış veri üretir.</a:t>
             </a:r>
           </a:p>
         </p:txBody>
@@ -5406,7 +5804,7 @@
         <p:spPr>
           <a:xfrm>
             <a:off x="685800" y="2606040"/>
-            <a:ext cx="6995160" cy="3246120"/>
+            <a:ext cx="5806440" cy="3246120"/>
           </a:xfrm>
           <a:prstGeom prst="roundRect">
             <a:avLst/>
@@ -5450,8 +5848,8 @@
         </p:nvSpPr>
         <p:spPr>
           <a:xfrm>
-            <a:off x="987552" y="2907792"/>
-            <a:ext cx="274320" cy="320040"/>
+            <a:off x="960120" y="2907792"/>
+            <a:ext cx="228600" cy="274320"/>
           </a:xfrm>
           <a:prstGeom prst="rect">
             <a:avLst/>
@@ -5459,20 +5857,19 @@
           <a:noFill/>
         </p:spPr>
         <p:txBody>
-          <a:bodyPr wrap="none">
+          <a:bodyPr wrap="square" lIns="27432" rIns="27432" tIns="18288" bIns="18288">
             <a:spAutoFit/>
           </a:bodyPr>
           <a:lstStyle/>
           <a:p>
-            <a:pPr>
-              <a:defRPr sz="1400" b="1">
+            <a:pPr algn="l"/>
+            <a:r>
+              <a:rPr sz="1500" b="1">
                 <a:solidFill>
                   <a:srgbClr val="66F1BE"/>
                 </a:solidFill>
                 <a:latin typeface="Arial"/>
-              </a:defRPr>
-            </a:pPr>
-            <a:r>
+              </a:rPr>
               <a:t>•</a:t>
             </a:r>
           </a:p>
@@ -5486,8 +5883,8 @@
         </p:nvSpPr>
         <p:spPr>
           <a:xfrm>
-            <a:off x="1298448" y="2889504"/>
-            <a:ext cx="5897880" cy="502920"/>
+            <a:off x="1261872" y="2898648"/>
+            <a:ext cx="4800600" cy="438912"/>
           </a:xfrm>
           <a:prstGeom prst="rect">
             <a:avLst/>
@@ -5495,21 +5892,20 @@
           <a:noFill/>
         </p:spPr>
         <p:txBody>
-          <a:bodyPr wrap="none">
+          <a:bodyPr wrap="square" lIns="27432" rIns="27432" tIns="18288" bIns="18288">
             <a:spAutoFit/>
           </a:bodyPr>
           <a:lstStyle/>
           <a:p>
-            <a:pPr>
-              <a:defRPr sz="1400" b="0">
+            <a:pPr algn="l"/>
+            <a:r>
+              <a:rPr sz="1200" b="0">
                 <a:solidFill>
                   <a:srgbClr val="F0F3F8"/>
                 </a:solidFill>
                 <a:latin typeface="Arial"/>
-              </a:defRPr>
-            </a:pPr>
-            <a:r>
-              <a:t>Predictable fields for every slide</a:t>
+              </a:rPr>
+              <a:t>Her slayt için öngörülebilir alanlar kullanılır</a:t>
             </a:r>
           </a:p>
         </p:txBody>
@@ -5522,8 +5918,8 @@
         </p:nvSpPr>
         <p:spPr>
           <a:xfrm>
-            <a:off x="987552" y="3438144"/>
-            <a:ext cx="274320" cy="320040"/>
+            <a:off x="960120" y="3438144"/>
+            <a:ext cx="228600" cy="274320"/>
           </a:xfrm>
           <a:prstGeom prst="rect">
             <a:avLst/>
@@ -5531,20 +5927,19 @@
           <a:noFill/>
         </p:spPr>
         <p:txBody>
-          <a:bodyPr wrap="none">
+          <a:bodyPr wrap="square" lIns="27432" rIns="27432" tIns="18288" bIns="18288">
             <a:spAutoFit/>
           </a:bodyPr>
           <a:lstStyle/>
           <a:p>
-            <a:pPr>
-              <a:defRPr sz="1400" b="1">
+            <a:pPr algn="l"/>
+            <a:r>
+              <a:rPr sz="1500" b="1">
                 <a:solidFill>
                   <a:srgbClr val="66F1BE"/>
                 </a:solidFill>
                 <a:latin typeface="Arial"/>
-              </a:defRPr>
-            </a:pPr>
-            <a:r>
+              </a:rPr>
               <a:t>•</a:t>
             </a:r>
           </a:p>
@@ -5558,8 +5953,8 @@
         </p:nvSpPr>
         <p:spPr>
           <a:xfrm>
-            <a:off x="1298448" y="3419856"/>
-            <a:ext cx="5897880" cy="502920"/>
+            <a:off x="1261872" y="3429000"/>
+            <a:ext cx="4800600" cy="438912"/>
           </a:xfrm>
           <a:prstGeom prst="rect">
             <a:avLst/>
@@ -5567,21 +5962,20 @@
           <a:noFill/>
         </p:spPr>
         <p:txBody>
-          <a:bodyPr wrap="none">
+          <a:bodyPr wrap="square" lIns="27432" rIns="27432" tIns="18288" bIns="18288">
             <a:spAutoFit/>
           </a:bodyPr>
           <a:lstStyle/>
           <a:p>
-            <a:pPr>
-              <a:defRPr sz="1400" b="0">
+            <a:pPr algn="l"/>
+            <a:r>
+              <a:rPr sz="1200" b="0">
                 <a:solidFill>
                   <a:srgbClr val="F0F3F8"/>
                 </a:solidFill>
                 <a:latin typeface="Arial"/>
-              </a:defRPr>
-            </a:pPr>
-            <a:r>
-              <a:t>Validation before rendering</a:t>
+              </a:rPr>
+              <a:t>PPTX üretiminden önce JSON doğrulaması yapılır</a:t>
             </a:r>
           </a:p>
         </p:txBody>
@@ -5594,8 +5988,8 @@
         </p:nvSpPr>
         <p:spPr>
           <a:xfrm>
-            <a:off x="987552" y="3968496"/>
-            <a:ext cx="274320" cy="320040"/>
+            <a:off x="960120" y="3968496"/>
+            <a:ext cx="228600" cy="274320"/>
           </a:xfrm>
           <a:prstGeom prst="rect">
             <a:avLst/>
@@ -5603,20 +5997,19 @@
           <a:noFill/>
         </p:spPr>
         <p:txBody>
-          <a:bodyPr wrap="none">
+          <a:bodyPr wrap="square" lIns="27432" rIns="27432" tIns="18288" bIns="18288">
             <a:spAutoFit/>
           </a:bodyPr>
           <a:lstStyle/>
           <a:p>
-            <a:pPr>
-              <a:defRPr sz="1400" b="1">
+            <a:pPr algn="l"/>
+            <a:r>
+              <a:rPr sz="1500" b="1">
                 <a:solidFill>
                   <a:srgbClr val="66F1BE"/>
                 </a:solidFill>
                 <a:latin typeface="Arial"/>
-              </a:defRPr>
-            </a:pPr>
-            <a:r>
+              </a:rPr>
               <a:t>•</a:t>
             </a:r>
           </a:p>
@@ -5630,8 +6023,8 @@
         </p:nvSpPr>
         <p:spPr>
           <a:xfrm>
-            <a:off x="1298448" y="3950208"/>
-            <a:ext cx="5897880" cy="502920"/>
+            <a:off x="1261872" y="3959352"/>
+            <a:ext cx="4800600" cy="438912"/>
           </a:xfrm>
           <a:prstGeom prst="rect">
             <a:avLst/>
@@ -5639,21 +6032,20 @@
           <a:noFill/>
         </p:spPr>
         <p:txBody>
-          <a:bodyPr wrap="none">
+          <a:bodyPr wrap="square" lIns="27432" rIns="27432" tIns="18288" bIns="18288">
             <a:spAutoFit/>
           </a:bodyPr>
           <a:lstStyle/>
           <a:p>
-            <a:pPr>
-              <a:defRPr sz="1400" b="0">
+            <a:pPr algn="l"/>
+            <a:r>
+              <a:rPr sz="1200" b="0">
                 <a:solidFill>
                   <a:srgbClr val="F0F3F8"/>
                 </a:solidFill>
                 <a:latin typeface="Arial"/>
-              </a:defRPr>
-            </a:pPr>
-            <a:r>
-              <a:t>Renderer can be replaced without changing prompts</a:t>
+              </a:rPr>
+              <a:t>Prompt'lar değiştirilmeden PPTX motoru geliştirilebilir</a:t>
             </a:r>
           </a:p>
         </p:txBody>
@@ -5666,8 +6058,8 @@
         </p:nvSpPr>
         <p:spPr>
           <a:xfrm>
-            <a:off x="987552" y="4498848"/>
-            <a:ext cx="274320" cy="320040"/>
+            <a:off x="960120" y="4498848"/>
+            <a:ext cx="228600" cy="274320"/>
           </a:xfrm>
           <a:prstGeom prst="rect">
             <a:avLst/>
@@ -5675,20 +6067,19 @@
           <a:noFill/>
         </p:spPr>
         <p:txBody>
-          <a:bodyPr wrap="none">
+          <a:bodyPr wrap="square" lIns="27432" rIns="27432" tIns="18288" bIns="18288">
             <a:spAutoFit/>
           </a:bodyPr>
           <a:lstStyle/>
           <a:p>
-            <a:pPr>
-              <a:defRPr sz="1400" b="1">
+            <a:pPr algn="l"/>
+            <a:r>
+              <a:rPr sz="1500" b="1">
                 <a:solidFill>
                   <a:srgbClr val="66F1BE"/>
                 </a:solidFill>
                 <a:latin typeface="Arial"/>
-              </a:defRPr>
-            </a:pPr>
-            <a:r>
+              </a:rPr>
               <a:t>•</a:t>
             </a:r>
           </a:p>
@@ -5702,8 +6093,8 @@
         </p:nvSpPr>
         <p:spPr>
           <a:xfrm>
-            <a:off x="1298448" y="4480560"/>
-            <a:ext cx="5897880" cy="502920"/>
+            <a:off x="1261872" y="4489704"/>
+            <a:ext cx="4800600" cy="438912"/>
           </a:xfrm>
           <a:prstGeom prst="rect">
             <a:avLst/>
@@ -5711,21 +6102,20 @@
           <a:noFill/>
         </p:spPr>
         <p:txBody>
-          <a:bodyPr wrap="none">
+          <a:bodyPr wrap="square" lIns="27432" rIns="27432" tIns="18288" bIns="18288">
             <a:spAutoFit/>
           </a:bodyPr>
           <a:lstStyle/>
           <a:p>
-            <a:pPr>
-              <a:defRPr sz="1400" b="0">
+            <a:pPr algn="l"/>
+            <a:r>
+              <a:rPr sz="1200" b="0">
                 <a:solidFill>
                   <a:srgbClr val="F0F3F8"/>
                 </a:solidFill>
                 <a:latin typeface="Arial"/>
-              </a:defRPr>
-            </a:pPr>
-            <a:r>
-              <a:t>Model can be replaced without changing PPTX code</a:t>
+              </a:rPr>
+              <a:t>PPTX kodu değiştirilmeden model sağlayıcısı değiştirilebilir</a:t>
             </a:r>
           </a:p>
         </p:txBody>
@@ -5738,8 +6128,8 @@
         </p:nvSpPr>
         <p:spPr>
           <a:xfrm>
-            <a:off x="7955279" y="2606040"/>
-            <a:ext cx="3520440" cy="3246120"/>
+            <a:off x="6766560" y="2606040"/>
+            <a:ext cx="4709160" cy="3246120"/>
           </a:xfrm>
           <a:prstGeom prst="roundRect">
             <a:avLst/>
@@ -5783,8 +6173,8 @@
         </p:nvSpPr>
         <p:spPr>
           <a:xfrm>
-            <a:off x="8275320" y="2907792"/>
-            <a:ext cx="2468880" cy="274320"/>
+            <a:off x="7086600" y="2880360"/>
+            <a:ext cx="2286000" cy="228600"/>
           </a:xfrm>
           <a:prstGeom prst="rect">
             <a:avLst/>
@@ -5792,21 +6182,20 @@
           <a:noFill/>
         </p:spPr>
         <p:txBody>
-          <a:bodyPr wrap="none">
+          <a:bodyPr wrap="square" lIns="27432" rIns="27432" tIns="18288" bIns="18288">
             <a:spAutoFit/>
           </a:bodyPr>
           <a:lstStyle/>
           <a:p>
-            <a:pPr>
-              <a:defRPr sz="800" b="1">
+            <a:pPr algn="l"/>
+            <a:r>
+              <a:rPr sz="800" b="1">
                 <a:solidFill>
                   <a:srgbClr val="66F1BE"/>
                 </a:solidFill>
                 <a:latin typeface="Arial"/>
-              </a:defRPr>
-            </a:pPr>
-            <a:r>
-              <a:t>VISUAL DIRECTION</a:t>
+              </a:rPr>
+              <a:t>YAPILANDIRILMIŞ JSON</a:t>
             </a:r>
           </a:p>
         </p:txBody>
@@ -5819,8 +6208,8 @@
         </p:nvSpPr>
         <p:spPr>
           <a:xfrm>
-            <a:off x="8275320" y="3383280"/>
-            <a:ext cx="2697480" cy="1508760"/>
+            <a:off x="7178040" y="3337560"/>
+            <a:ext cx="3794760" cy="2057400"/>
           </a:xfrm>
           <a:prstGeom prst="rect">
             <a:avLst/>
@@ -5828,21 +6217,100 @@
           <a:noFill/>
         </p:spPr>
         <p:txBody>
-          <a:bodyPr wrap="none">
+          <a:bodyPr wrap="square" lIns="27432" rIns="27432" tIns="18288" bIns="18288">
             <a:spAutoFit/>
           </a:bodyPr>
           <a:lstStyle/>
           <a:p>
-            <a:pPr>
-              <a:defRPr sz="1400" b="0">
+            <a:pPr algn="l"/>
+            <a:r>
+              <a:rPr sz="1200" b="0">
                 <a:solidFill>
                   <a:srgbClr val="F0F3F8"/>
                 </a:solidFill>
                 <a:latin typeface="Arial"/>
-              </a:defRPr>
-            </a:pPr>
-            <a:r>
-              <a:t>JSON object in the center with AI on the left and PPTX on the right</a:t>
+              </a:rPr>
+              <a:t>{</a:t>
+            </a:r>
+            <a:br/>
+            <a:r>
+              <a:rPr sz="1200" b="0">
+                <a:solidFill>
+                  <a:srgbClr val="F0F3F8"/>
+                </a:solidFill>
+                <a:latin typeface="Arial"/>
+              </a:rPr>
+              <a:t>  "title": "...",</a:t>
+            </a:r>
+            <a:br/>
+            <a:r>
+              <a:rPr sz="1200" b="0">
+                <a:solidFill>
+                  <a:srgbClr val="F0F3F8"/>
+                </a:solidFill>
+                <a:latin typeface="Arial"/>
+              </a:rPr>
+              <a:t>  "slides": [</a:t>
+            </a:r>
+            <a:br/>
+            <a:r>
+              <a:rPr sz="1200" b="0">
+                <a:solidFill>
+                  <a:srgbClr val="F0F3F8"/>
+                </a:solidFill>
+                <a:latin typeface="Arial"/>
+              </a:rPr>
+              <a:t>    {</a:t>
+            </a:r>
+            <a:br/>
+            <a:r>
+              <a:rPr sz="1200" b="0">
+                <a:solidFill>
+                  <a:srgbClr val="F0F3F8"/>
+                </a:solidFill>
+                <a:latin typeface="Arial"/>
+              </a:rPr>
+              <a:t>      "title": "...",</a:t>
+            </a:r>
+            <a:br/>
+            <a:r>
+              <a:rPr sz="1200" b="0">
+                <a:solidFill>
+                  <a:srgbClr val="F0F3F8"/>
+                </a:solidFill>
+                <a:latin typeface="Arial"/>
+              </a:rPr>
+              <a:t>      "content": [...]</a:t>
+            </a:r>
+            <a:br/>
+            <a:r>
+              <a:rPr sz="1200" b="0">
+                <a:solidFill>
+                  <a:srgbClr val="F0F3F8"/>
+                </a:solidFill>
+                <a:latin typeface="Arial"/>
+              </a:rPr>
+              <a:t>    }</a:t>
+            </a:r>
+            <a:br/>
+            <a:r>
+              <a:rPr sz="1200" b="0">
+                <a:solidFill>
+                  <a:srgbClr val="F0F3F8"/>
+                </a:solidFill>
+                <a:latin typeface="Arial"/>
+              </a:rPr>
+              <a:t>  ]</a:t>
+            </a:r>
+            <a:br/>
+            <a:r>
+              <a:rPr sz="1200" b="0">
+                <a:solidFill>
+                  <a:srgbClr val="F0F3F8"/>
+                </a:solidFill>
+                <a:latin typeface="Arial"/>
+              </a:rPr>
+              <a:t>}</a:t>
             </a:r>
           </a:p>
         </p:txBody>
@@ -5856,7 +6324,7 @@
         <p:spPr>
           <a:xfrm>
             <a:off x="11155680" y="6446520"/>
-            <a:ext cx="548640" cy="228600"/>
+            <a:ext cx="502920" cy="182880"/>
           </a:xfrm>
           <a:prstGeom prst="rect">
             <a:avLst/>
@@ -5864,20 +6332,19 @@
           <a:noFill/>
         </p:spPr>
         <p:txBody>
-          <a:bodyPr wrap="none">
+          <a:bodyPr wrap="square" lIns="27432" rIns="27432" tIns="18288" bIns="18288">
             <a:spAutoFit/>
           </a:bodyPr>
           <a:lstStyle/>
           <a:p>
-            <a:pPr>
-              <a:defRPr sz="800" b="0">
+            <a:pPr algn="l"/>
+            <a:r>
+              <a:rPr sz="800" b="0">
                 <a:solidFill>
                   <a:srgbClr val="A3ABB8"/>
                 </a:solidFill>
                 <a:latin typeface="Arial"/>
-              </a:defRPr>
-            </a:pPr>
-            <a:r>
+              </a:rPr>
               <a:t>03</a:t>
             </a:r>
           </a:p>
@@ -5926,21 +6393,20 @@
           <a:noFill/>
         </p:spPr>
         <p:txBody>
-          <a:bodyPr wrap="none">
+          <a:bodyPr wrap="square" lIns="27432" rIns="27432" tIns="18288" bIns="18288">
             <a:spAutoFit/>
           </a:bodyPr>
           <a:lstStyle/>
           <a:p>
-            <a:pPr>
-              <a:defRPr sz="800" b="1">
+            <a:pPr algn="l"/>
+            <a:r>
+              <a:rPr sz="800" b="1">
                 <a:solidFill>
                   <a:srgbClr val="66F1BE"/>
                 </a:solidFill>
                 <a:latin typeface="Arial"/>
-              </a:defRPr>
-            </a:pPr>
-            <a:r>
-              <a:t>SLIDE 04</a:t>
+              </a:rPr>
+              <a:t>SLAYT 04</a:t>
             </a:r>
           </a:p>
         </p:txBody>
@@ -5954,7 +6420,7 @@
         <p:spPr>
           <a:xfrm>
             <a:off x="685800" y="914400"/>
-            <a:ext cx="10607040" cy="822960"/>
+            <a:ext cx="10607040" cy="640080"/>
           </a:xfrm>
           <a:prstGeom prst="rect">
             <a:avLst/>
@@ -5962,21 +6428,20 @@
           <a:noFill/>
         </p:spPr>
         <p:txBody>
-          <a:bodyPr wrap="none">
+          <a:bodyPr wrap="square" lIns="27432" rIns="27432" tIns="18288" bIns="18288">
             <a:spAutoFit/>
           </a:bodyPr>
           <a:lstStyle/>
           <a:p>
-            <a:pPr>
-              <a:defRPr sz="2500" b="1">
+            <a:pPr algn="l"/>
+            <a:r>
+              <a:rPr sz="2500" b="1">
                 <a:solidFill>
                   <a:srgbClr val="F0F3F8"/>
                 </a:solidFill>
                 <a:latin typeface="Arial"/>
-              </a:defRPr>
-            </a:pPr>
-            <a:r>
-              <a:t>The demo runs without a paid AI API</a:t>
+              </a:rPr>
+              <a:t>Demo, ücretli bir yapay zeka API'si olmadan çalışır</a:t>
             </a:r>
           </a:p>
         </p:txBody>
@@ -5990,7 +6455,7 @@
         <p:spPr>
           <a:xfrm>
             <a:off x="713232" y="1783080"/>
-            <a:ext cx="9875520" cy="594360"/>
+            <a:ext cx="10515600" cy="685800"/>
           </a:xfrm>
           <a:prstGeom prst="rect">
             <a:avLst/>
@@ -5998,21 +6463,20 @@
           <a:noFill/>
         </p:spPr>
         <p:txBody>
-          <a:bodyPr wrap="none">
+          <a:bodyPr wrap="square" lIns="27432" rIns="27432" tIns="18288" bIns="18288">
             <a:spAutoFit/>
           </a:bodyPr>
           <a:lstStyle/>
           <a:p>
-            <a:pPr>
-              <a:defRPr sz="1300" b="0">
+            <a:pPr algn="l"/>
+            <a:r>
+              <a:rPr sz="1300" b="0">
                 <a:solidFill>
                   <a:srgbClr val="A3ABB8"/>
                 </a:solidFill>
                 <a:latin typeface="Arial"/>
-              </a:defRPr>
-            </a:pPr>
-            <a:r>
-              <a:t>A deterministic demo proves the renderer independently of any model provider.</a:t>
+              </a:rPr>
+              <a:t>Deterministik demo, PPTX motorunun herhangi bir yapay zeka sağlayıcısına ihtiyaç duymadan çalışabildiğini gösterir.</a:t>
             </a:r>
           </a:p>
         </p:txBody>
@@ -6026,7 +6490,7 @@
         <p:spPr>
           <a:xfrm>
             <a:off x="685800" y="2606040"/>
-            <a:ext cx="6995160" cy="3246120"/>
+            <a:ext cx="5806440" cy="3246120"/>
           </a:xfrm>
           <a:prstGeom prst="roundRect">
             <a:avLst/>
@@ -6070,8 +6534,8 @@
         </p:nvSpPr>
         <p:spPr>
           <a:xfrm>
-            <a:off x="987552" y="2907792"/>
-            <a:ext cx="274320" cy="320040"/>
+            <a:off x="960120" y="2907792"/>
+            <a:ext cx="228600" cy="274320"/>
           </a:xfrm>
           <a:prstGeom prst="rect">
             <a:avLst/>
@@ -6079,20 +6543,19 @@
           <a:noFill/>
         </p:spPr>
         <p:txBody>
-          <a:bodyPr wrap="none">
+          <a:bodyPr wrap="square" lIns="27432" rIns="27432" tIns="18288" bIns="18288">
             <a:spAutoFit/>
           </a:bodyPr>
           <a:lstStyle/>
           <a:p>
-            <a:pPr>
-              <a:defRPr sz="1400" b="1">
+            <a:pPr algn="l"/>
+            <a:r>
+              <a:rPr sz="1500" b="1">
                 <a:solidFill>
                   <a:srgbClr val="66F1BE"/>
                 </a:solidFill>
                 <a:latin typeface="Arial"/>
-              </a:defRPr>
-            </a:pPr>
-            <a:r>
+              </a:rPr>
               <a:t>•</a:t>
             </a:r>
           </a:p>
@@ -6106,8 +6569,8 @@
         </p:nvSpPr>
         <p:spPr>
           <a:xfrm>
-            <a:off x="1298448" y="2889504"/>
-            <a:ext cx="5897880" cy="502920"/>
+            <a:off x="1261872" y="2898648"/>
+            <a:ext cx="4800600" cy="438912"/>
           </a:xfrm>
           <a:prstGeom prst="rect">
             <a:avLst/>
@@ -6115,21 +6578,20 @@
           <a:noFill/>
         </p:spPr>
         <p:txBody>
-          <a:bodyPr wrap="none">
+          <a:bodyPr wrap="square" lIns="27432" rIns="27432" tIns="18288" bIns="18288">
             <a:spAutoFit/>
           </a:bodyPr>
           <a:lstStyle/>
           <a:p>
-            <a:pPr>
-              <a:defRPr sz="1400" b="0">
+            <a:pPr algn="l"/>
+            <a:r>
+              <a:rPr sz="1200" b="0">
                 <a:solidFill>
                   <a:srgbClr val="F0F3F8"/>
                 </a:solidFill>
                 <a:latin typeface="Arial"/>
-              </a:defRPr>
-            </a:pPr>
-            <a:r>
-              <a:t>python app.py --demo</a:t>
+              </a:rPr>
+              <a:t>python app.py --demo komutu çalıştırılır</a:t>
             </a:r>
           </a:p>
         </p:txBody>
@@ -6142,8 +6604,8 @@
         </p:nvSpPr>
         <p:spPr>
           <a:xfrm>
-            <a:off x="987552" y="3438144"/>
-            <a:ext cx="274320" cy="320040"/>
+            <a:off x="960120" y="3438144"/>
+            <a:ext cx="228600" cy="274320"/>
           </a:xfrm>
           <a:prstGeom prst="rect">
             <a:avLst/>
@@ -6151,20 +6613,19 @@
           <a:noFill/>
         </p:spPr>
         <p:txBody>
-          <a:bodyPr wrap="none">
+          <a:bodyPr wrap="square" lIns="27432" rIns="27432" tIns="18288" bIns="18288">
             <a:spAutoFit/>
           </a:bodyPr>
           <a:lstStyle/>
           <a:p>
-            <a:pPr>
-              <a:defRPr sz="1400" b="1">
+            <a:pPr algn="l"/>
+            <a:r>
+              <a:rPr sz="1500" b="1">
                 <a:solidFill>
                   <a:srgbClr val="66F1BE"/>
                 </a:solidFill>
                 <a:latin typeface="Arial"/>
-              </a:defRPr>
-            </a:pPr>
-            <a:r>
+              </a:rPr>
               <a:t>•</a:t>
             </a:r>
           </a:p>
@@ -6178,8 +6639,8 @@
         </p:nvSpPr>
         <p:spPr>
           <a:xfrm>
-            <a:off x="1298448" y="3419856"/>
-            <a:ext cx="5897880" cy="502920"/>
+            <a:off x="1261872" y="3429000"/>
+            <a:ext cx="4800600" cy="438912"/>
           </a:xfrm>
           <a:prstGeom prst="rect">
             <a:avLst/>
@@ -6187,21 +6648,20 @@
           <a:noFill/>
         </p:spPr>
         <p:txBody>
-          <a:bodyPr wrap="none">
+          <a:bodyPr wrap="square" lIns="27432" rIns="27432" tIns="18288" bIns="18288">
             <a:spAutoFit/>
           </a:bodyPr>
           <a:lstStyle/>
           <a:p>
-            <a:pPr>
-              <a:defRPr sz="1400" b="0">
+            <a:pPr algn="l"/>
+            <a:r>
+              <a:rPr sz="1200" b="0">
                 <a:solidFill>
                   <a:srgbClr val="F0F3F8"/>
                 </a:solidFill>
                 <a:latin typeface="Arial"/>
-              </a:defRPr>
-            </a:pPr>
-            <a:r>
-              <a:t>Validates the sample JSON</a:t>
+              </a:rPr>
+              <a:t>Örnek sunum JSON'u doğrulanır</a:t>
             </a:r>
           </a:p>
         </p:txBody>
@@ -6214,8 +6674,8 @@
         </p:nvSpPr>
         <p:spPr>
           <a:xfrm>
-            <a:off x="987552" y="3968496"/>
-            <a:ext cx="274320" cy="320040"/>
+            <a:off x="960120" y="3968496"/>
+            <a:ext cx="228600" cy="274320"/>
           </a:xfrm>
           <a:prstGeom prst="rect">
             <a:avLst/>
@@ -6223,20 +6683,19 @@
           <a:noFill/>
         </p:spPr>
         <p:txBody>
-          <a:bodyPr wrap="none">
+          <a:bodyPr wrap="square" lIns="27432" rIns="27432" tIns="18288" bIns="18288">
             <a:spAutoFit/>
           </a:bodyPr>
           <a:lstStyle/>
           <a:p>
-            <a:pPr>
-              <a:defRPr sz="1400" b="1">
+            <a:pPr algn="l"/>
+            <a:r>
+              <a:rPr sz="1500" b="1">
                 <a:solidFill>
                   <a:srgbClr val="66F1BE"/>
                 </a:solidFill>
                 <a:latin typeface="Arial"/>
-              </a:defRPr>
-            </a:pPr>
-            <a:r>
+              </a:rPr>
               <a:t>•</a:t>
             </a:r>
           </a:p>
@@ -6250,8 +6709,8 @@
         </p:nvSpPr>
         <p:spPr>
           <a:xfrm>
-            <a:off x="1298448" y="3950208"/>
-            <a:ext cx="5897880" cy="502920"/>
+            <a:off x="1261872" y="3959352"/>
+            <a:ext cx="4800600" cy="438912"/>
           </a:xfrm>
           <a:prstGeom prst="rect">
             <a:avLst/>
@@ -6259,21 +6718,20 @@
           <a:noFill/>
         </p:spPr>
         <p:txBody>
-          <a:bodyPr wrap="none">
+          <a:bodyPr wrap="square" lIns="27432" rIns="27432" tIns="18288" bIns="18288">
             <a:spAutoFit/>
           </a:bodyPr>
           <a:lstStyle/>
           <a:p>
-            <a:pPr>
-              <a:defRPr sz="1400" b="0">
+            <a:pPr algn="l"/>
+            <a:r>
+              <a:rPr sz="1200" b="0">
                 <a:solidFill>
                   <a:srgbClr val="F0F3F8"/>
                 </a:solidFill>
                 <a:latin typeface="Arial"/>
-              </a:defRPr>
-            </a:pPr>
-            <a:r>
-              <a:t>Generates a native .pptx file</a:t>
+              </a:rPr>
+              <a:t>Düzenlenebilir bir .pptx dosyası oluşturulur</a:t>
             </a:r>
           </a:p>
         </p:txBody>
@@ -6286,8 +6744,8 @@
         </p:nvSpPr>
         <p:spPr>
           <a:xfrm>
-            <a:off x="987552" y="4498848"/>
-            <a:ext cx="274320" cy="320040"/>
+            <a:off x="960120" y="4498848"/>
+            <a:ext cx="228600" cy="274320"/>
           </a:xfrm>
           <a:prstGeom prst="rect">
             <a:avLst/>
@@ -6295,20 +6753,19 @@
           <a:noFill/>
         </p:spPr>
         <p:txBody>
-          <a:bodyPr wrap="none">
+          <a:bodyPr wrap="square" lIns="27432" rIns="27432" tIns="18288" bIns="18288">
             <a:spAutoFit/>
           </a:bodyPr>
           <a:lstStyle/>
           <a:p>
-            <a:pPr>
-              <a:defRPr sz="1400" b="1">
+            <a:pPr algn="l"/>
+            <a:r>
+              <a:rPr sz="1500" b="1">
                 <a:solidFill>
                   <a:srgbClr val="66F1BE"/>
                 </a:solidFill>
                 <a:latin typeface="Arial"/>
-              </a:defRPr>
-            </a:pPr>
-            <a:r>
+              </a:rPr>
               <a:t>•</a:t>
             </a:r>
           </a:p>
@@ -6322,8 +6779,8 @@
         </p:nvSpPr>
         <p:spPr>
           <a:xfrm>
-            <a:off x="1298448" y="4480560"/>
-            <a:ext cx="5897880" cy="502920"/>
+            <a:off x="1261872" y="4489704"/>
+            <a:ext cx="4800600" cy="438912"/>
           </a:xfrm>
           <a:prstGeom prst="rect">
             <a:avLst/>
@@ -6331,21 +6788,20 @@
           <a:noFill/>
         </p:spPr>
         <p:txBody>
-          <a:bodyPr wrap="none">
+          <a:bodyPr wrap="square" lIns="27432" rIns="27432" tIns="18288" bIns="18288">
             <a:spAutoFit/>
           </a:bodyPr>
           <a:lstStyle/>
           <a:p>
-            <a:pPr>
-              <a:defRPr sz="1400" b="0">
+            <a:pPr algn="l"/>
+            <a:r>
+              <a:rPr sz="1200" b="0">
                 <a:solidFill>
                   <a:srgbClr val="F0F3F8"/>
                 </a:solidFill>
                 <a:latin typeface="Arial"/>
-              </a:defRPr>
-            </a:pPr>
-            <a:r>
-              <a:t>Local Ollama mode can be enabled separately</a:t>
+              </a:rPr>
+              <a:t>Yerel Ollama modeli ayrı olarak etkinleştirilebilir</a:t>
             </a:r>
           </a:p>
         </p:txBody>
@@ -6358,8 +6814,8 @@
         </p:nvSpPr>
         <p:spPr>
           <a:xfrm>
-            <a:off x="7955279" y="2606040"/>
-            <a:ext cx="3520440" cy="3246120"/>
+            <a:off x="6766560" y="2606040"/>
+            <a:ext cx="4709160" cy="3246120"/>
           </a:xfrm>
           <a:prstGeom prst="roundRect">
             <a:avLst/>
@@ -6403,8 +6859,8 @@
         </p:nvSpPr>
         <p:spPr>
           <a:xfrm>
-            <a:off x="8275320" y="2907792"/>
-            <a:ext cx="2468880" cy="274320"/>
+            <a:off x="7086600" y="2880360"/>
+            <a:ext cx="2286000" cy="228600"/>
           </a:xfrm>
           <a:prstGeom prst="rect">
             <a:avLst/>
@@ -6412,21 +6868,20 @@
           <a:noFill/>
         </p:spPr>
         <p:txBody>
-          <a:bodyPr wrap="none">
+          <a:bodyPr wrap="square" lIns="27432" rIns="27432" tIns="18288" bIns="18288">
             <a:spAutoFit/>
           </a:bodyPr>
           <a:lstStyle/>
           <a:p>
-            <a:pPr>
-              <a:defRPr sz="800" b="1">
+            <a:pPr algn="l"/>
+            <a:r>
+              <a:rPr sz="800" b="1">
                 <a:solidFill>
                   <a:srgbClr val="66F1BE"/>
                 </a:solidFill>
                 <a:latin typeface="Arial"/>
-              </a:defRPr>
-            </a:pPr>
-            <a:r>
-              <a:t>VISUAL DIRECTION</a:t>
+              </a:rPr>
+              <a:t>YAPILANDIRILMIŞ JSON</a:t>
             </a:r>
           </a:p>
         </p:txBody>
@@ -6439,8 +6894,8 @@
         </p:nvSpPr>
         <p:spPr>
           <a:xfrm>
-            <a:off x="8275320" y="3383280"/>
-            <a:ext cx="2697480" cy="1508760"/>
+            <a:off x="7178040" y="3337560"/>
+            <a:ext cx="3794760" cy="2057400"/>
           </a:xfrm>
           <a:prstGeom prst="rect">
             <a:avLst/>
@@ -6448,21 +6903,100 @@
           <a:noFill/>
         </p:spPr>
         <p:txBody>
-          <a:bodyPr wrap="none">
+          <a:bodyPr wrap="square" lIns="27432" rIns="27432" tIns="18288" bIns="18288">
             <a:spAutoFit/>
           </a:bodyPr>
           <a:lstStyle/>
           <a:p>
-            <a:pPr>
-              <a:defRPr sz="1400" b="0">
+            <a:pPr algn="l"/>
+            <a:r>
+              <a:rPr sz="1200" b="0">
                 <a:solidFill>
                   <a:srgbClr val="F0F3F8"/>
                 </a:solidFill>
                 <a:latin typeface="Arial"/>
-              </a:defRPr>
-            </a:pPr>
-            <a:r>
-              <a:t>Terminal command flowing into a generated PowerPoint file</a:t>
+              </a:rPr>
+              <a:t>{</a:t>
+            </a:r>
+            <a:br/>
+            <a:r>
+              <a:rPr sz="1200" b="0">
+                <a:solidFill>
+                  <a:srgbClr val="F0F3F8"/>
+                </a:solidFill>
+                <a:latin typeface="Arial"/>
+              </a:rPr>
+              <a:t>  "title": "...",</a:t>
+            </a:r>
+            <a:br/>
+            <a:r>
+              <a:rPr sz="1200" b="0">
+                <a:solidFill>
+                  <a:srgbClr val="F0F3F8"/>
+                </a:solidFill>
+                <a:latin typeface="Arial"/>
+              </a:rPr>
+              <a:t>  "slides": [</a:t>
+            </a:r>
+            <a:br/>
+            <a:r>
+              <a:rPr sz="1200" b="0">
+                <a:solidFill>
+                  <a:srgbClr val="F0F3F8"/>
+                </a:solidFill>
+                <a:latin typeface="Arial"/>
+              </a:rPr>
+              <a:t>    {</a:t>
+            </a:r>
+            <a:br/>
+            <a:r>
+              <a:rPr sz="1200" b="0">
+                <a:solidFill>
+                  <a:srgbClr val="F0F3F8"/>
+                </a:solidFill>
+                <a:latin typeface="Arial"/>
+              </a:rPr>
+              <a:t>      "title": "...",</a:t>
+            </a:r>
+            <a:br/>
+            <a:r>
+              <a:rPr sz="1200" b="0">
+                <a:solidFill>
+                  <a:srgbClr val="F0F3F8"/>
+                </a:solidFill>
+                <a:latin typeface="Arial"/>
+              </a:rPr>
+              <a:t>      "content": [...]</a:t>
+            </a:r>
+            <a:br/>
+            <a:r>
+              <a:rPr sz="1200" b="0">
+                <a:solidFill>
+                  <a:srgbClr val="F0F3F8"/>
+                </a:solidFill>
+                <a:latin typeface="Arial"/>
+              </a:rPr>
+              <a:t>    }</a:t>
+            </a:r>
+            <a:br/>
+            <a:r>
+              <a:rPr sz="1200" b="0">
+                <a:solidFill>
+                  <a:srgbClr val="F0F3F8"/>
+                </a:solidFill>
+                <a:latin typeface="Arial"/>
+              </a:rPr>
+              <a:t>  ]</a:t>
+            </a:r>
+            <a:br/>
+            <a:r>
+              <a:rPr sz="1200" b="0">
+                <a:solidFill>
+                  <a:srgbClr val="F0F3F8"/>
+                </a:solidFill>
+                <a:latin typeface="Arial"/>
+              </a:rPr>
+              <a:t>}</a:t>
             </a:r>
           </a:p>
         </p:txBody>
@@ -6476,7 +7010,7 @@
         <p:spPr>
           <a:xfrm>
             <a:off x="11155680" y="6446520"/>
-            <a:ext cx="548640" cy="228600"/>
+            <a:ext cx="502920" cy="182880"/>
           </a:xfrm>
           <a:prstGeom prst="rect">
             <a:avLst/>
@@ -6484,20 +7018,19 @@
           <a:noFill/>
         </p:spPr>
         <p:txBody>
-          <a:bodyPr wrap="none">
+          <a:bodyPr wrap="square" lIns="27432" rIns="27432" tIns="18288" bIns="18288">
             <a:spAutoFit/>
           </a:bodyPr>
           <a:lstStyle/>
           <a:p>
-            <a:pPr>
-              <a:defRPr sz="800" b="0">
+            <a:pPr algn="l"/>
+            <a:r>
+              <a:rPr sz="800" b="0">
                 <a:solidFill>
                   <a:srgbClr val="A3ABB8"/>
                 </a:solidFill>
                 <a:latin typeface="Arial"/>
-              </a:defRPr>
-            </a:pPr>
-            <a:r>
+              </a:rPr>
               <a:t>04</a:t>
             </a:r>
           </a:p>
@@ -6546,21 +7079,20 @@
           <a:noFill/>
         </p:spPr>
         <p:txBody>
-          <a:bodyPr wrap="none">
+          <a:bodyPr wrap="square" lIns="27432" rIns="27432" tIns="18288" bIns="18288">
             <a:spAutoFit/>
           </a:bodyPr>
           <a:lstStyle/>
           <a:p>
-            <a:pPr>
-              <a:defRPr sz="800" b="1">
+            <a:pPr algn="l"/>
+            <a:r>
+              <a:rPr sz="800" b="1">
                 <a:solidFill>
                   <a:srgbClr val="66F1BE"/>
                 </a:solidFill>
                 <a:latin typeface="Arial"/>
-              </a:defRPr>
-            </a:pPr>
-            <a:r>
-              <a:t>SLIDE 05</a:t>
+              </a:rPr>
+              <a:t>SLAYT 05</a:t>
             </a:r>
           </a:p>
         </p:txBody>
@@ -6574,7 +7106,7 @@
         <p:spPr>
           <a:xfrm>
             <a:off x="685800" y="914400"/>
-            <a:ext cx="10607040" cy="822960"/>
+            <a:ext cx="10607040" cy="640080"/>
           </a:xfrm>
           <a:prstGeom prst="rect">
             <a:avLst/>
@@ -6582,21 +7114,20 @@
           <a:noFill/>
         </p:spPr>
         <p:txBody>
-          <a:bodyPr wrap="none">
+          <a:bodyPr wrap="square" lIns="27432" rIns="27432" tIns="18288" bIns="18288">
             <a:spAutoFit/>
           </a:bodyPr>
           <a:lstStyle/>
           <a:p>
-            <a:pPr>
-              <a:defRPr sz="2500" b="1">
+            <a:pPr algn="l"/>
+            <a:r>
+              <a:rPr sz="2500" b="1">
                 <a:solidFill>
                   <a:srgbClr val="F0F3F8"/>
                 </a:solidFill>
                 <a:latin typeface="Arial"/>
-              </a:defRPr>
-            </a:pPr>
-            <a:r>
-              <a:t>Local AI keeps the architecture provider-independent</a:t>
+              </a:rPr>
+              <a:t>Yerel yapay zeka, mimariyi model sağlayıcısından bağımsız tutar</a:t>
             </a:r>
           </a:p>
         </p:txBody>
@@ -6610,7 +7141,7 @@
         <p:spPr>
           <a:xfrm>
             <a:off x="713232" y="1783080"/>
-            <a:ext cx="9875520" cy="594360"/>
+            <a:ext cx="10515600" cy="685800"/>
           </a:xfrm>
           <a:prstGeom prst="rect">
             <a:avLst/>
@@ -6618,21 +7149,20 @@
           <a:noFill/>
         </p:spPr>
         <p:txBody>
-          <a:bodyPr wrap="none">
+          <a:bodyPr wrap="square" lIns="27432" rIns="27432" tIns="18288" bIns="18288">
             <a:spAutoFit/>
           </a:bodyPr>
           <a:lstStyle/>
           <a:p>
-            <a:pPr>
-              <a:defRPr sz="1300" b="0">
+            <a:pPr algn="l"/>
+            <a:r>
+              <a:rPr sz="1300" b="0">
                 <a:solidFill>
                   <a:srgbClr val="A3ABB8"/>
                 </a:solidFill>
                 <a:latin typeface="Arial"/>
-              </a:defRPr>
-            </a:pPr>
-            <a:r>
-              <a:t>Ollama can generate the presentation JSON locally while the rest of the pipeline stays unchanged.</a:t>
+              </a:rPr>
+              <a:t>Ollama sunum JSON'unu yerel olarak üretirken iş akışının geri kalanı aynı şekilde çalışmaya devam eder.</a:t>
             </a:r>
           </a:p>
         </p:txBody>
@@ -6646,7 +7176,7 @@
         <p:spPr>
           <a:xfrm>
             <a:off x="685800" y="2606040"/>
-            <a:ext cx="6995160" cy="3246120"/>
+            <a:ext cx="5806440" cy="3246120"/>
           </a:xfrm>
           <a:prstGeom prst="roundRect">
             <a:avLst/>
@@ -6690,8 +7220,8 @@
         </p:nvSpPr>
         <p:spPr>
           <a:xfrm>
-            <a:off x="987552" y="2907792"/>
-            <a:ext cx="274320" cy="320040"/>
+            <a:off x="960120" y="2907792"/>
+            <a:ext cx="228600" cy="274320"/>
           </a:xfrm>
           <a:prstGeom prst="rect">
             <a:avLst/>
@@ -6699,20 +7229,19 @@
           <a:noFill/>
         </p:spPr>
         <p:txBody>
-          <a:bodyPr wrap="none">
+          <a:bodyPr wrap="square" lIns="27432" rIns="27432" tIns="18288" bIns="18288">
             <a:spAutoFit/>
           </a:bodyPr>
           <a:lstStyle/>
           <a:p>
-            <a:pPr>
-              <a:defRPr sz="1400" b="1">
+            <a:pPr algn="l"/>
+            <a:r>
+              <a:rPr sz="1500" b="1">
                 <a:solidFill>
                   <a:srgbClr val="66F1BE"/>
                 </a:solidFill>
                 <a:latin typeface="Arial"/>
-              </a:defRPr>
-            </a:pPr>
-            <a:r>
+              </a:rPr>
               <a:t>•</a:t>
             </a:r>
           </a:p>
@@ -6726,8 +7255,8 @@
         </p:nvSpPr>
         <p:spPr>
           <a:xfrm>
-            <a:off x="1298448" y="2889504"/>
-            <a:ext cx="5897880" cy="502920"/>
+            <a:off x="1261872" y="2898648"/>
+            <a:ext cx="4800600" cy="438912"/>
           </a:xfrm>
           <a:prstGeom prst="rect">
             <a:avLst/>
@@ -6735,21 +7264,20 @@
           <a:noFill/>
         </p:spPr>
         <p:txBody>
-          <a:bodyPr wrap="none">
+          <a:bodyPr wrap="square" lIns="27432" rIns="27432" tIns="18288" bIns="18288">
             <a:spAutoFit/>
           </a:bodyPr>
           <a:lstStyle/>
           <a:p>
-            <a:pPr>
-              <a:defRPr sz="1400" b="0">
+            <a:pPr algn="l"/>
+            <a:r>
+              <a:rPr sz="1200" b="0">
                 <a:solidFill>
                   <a:srgbClr val="F0F3F8"/>
                 </a:solidFill>
                 <a:latin typeface="Arial"/>
-              </a:defRPr>
-            </a:pPr>
-            <a:r>
-              <a:t>Local model receives the presentation skill</a:t>
+              </a:rPr>
+              <a:t>Yerel model Sunum Skill'ini kullanır</a:t>
             </a:r>
           </a:p>
         </p:txBody>
@@ -6762,8 +7290,8 @@
         </p:nvSpPr>
         <p:spPr>
           <a:xfrm>
-            <a:off x="987552" y="3438144"/>
-            <a:ext cx="274320" cy="320040"/>
+            <a:off x="960120" y="3438144"/>
+            <a:ext cx="228600" cy="274320"/>
           </a:xfrm>
           <a:prstGeom prst="rect">
             <a:avLst/>
@@ -6771,20 +7299,19 @@
           <a:noFill/>
         </p:spPr>
         <p:txBody>
-          <a:bodyPr wrap="none">
+          <a:bodyPr wrap="square" lIns="27432" rIns="27432" tIns="18288" bIns="18288">
             <a:spAutoFit/>
           </a:bodyPr>
           <a:lstStyle/>
           <a:p>
-            <a:pPr>
-              <a:defRPr sz="1400" b="1">
+            <a:pPr algn="l"/>
+            <a:r>
+              <a:rPr sz="1500" b="1">
                 <a:solidFill>
                   <a:srgbClr val="66F1BE"/>
                 </a:solidFill>
                 <a:latin typeface="Arial"/>
-              </a:defRPr>
-            </a:pPr>
-            <a:r>
+              </a:rPr>
               <a:t>•</a:t>
             </a:r>
           </a:p>
@@ -6798,8 +7325,8 @@
         </p:nvSpPr>
         <p:spPr>
           <a:xfrm>
-            <a:off x="1298448" y="3419856"/>
-            <a:ext cx="5897880" cy="502920"/>
+            <a:off x="1261872" y="3429000"/>
+            <a:ext cx="4800600" cy="438912"/>
           </a:xfrm>
           <a:prstGeom prst="rect">
             <a:avLst/>
@@ -6807,21 +7334,20 @@
           <a:noFill/>
         </p:spPr>
         <p:txBody>
-          <a:bodyPr wrap="none">
+          <a:bodyPr wrap="square" lIns="27432" rIns="27432" tIns="18288" bIns="18288">
             <a:spAutoFit/>
           </a:bodyPr>
           <a:lstStyle/>
           <a:p>
-            <a:pPr>
-              <a:defRPr sz="1400" b="0">
+            <a:pPr algn="l"/>
+            <a:r>
+              <a:rPr sz="1200" b="0">
                 <a:solidFill>
                   <a:srgbClr val="F0F3F8"/>
                 </a:solidFill>
                 <a:latin typeface="Arial"/>
-              </a:defRPr>
-            </a:pPr>
-            <a:r>
-              <a:t>JSON-only response is requested</a:t>
+              </a:rPr>
+              <a:t>Modelden yalnızca yapılandırılmış JSON çıktısı istenir</a:t>
             </a:r>
           </a:p>
         </p:txBody>
@@ -6834,8 +7360,8 @@
         </p:nvSpPr>
         <p:spPr>
           <a:xfrm>
-            <a:off x="987552" y="3968496"/>
-            <a:ext cx="274320" cy="320040"/>
+            <a:off x="960120" y="3968496"/>
+            <a:ext cx="228600" cy="274320"/>
           </a:xfrm>
           <a:prstGeom prst="rect">
             <a:avLst/>
@@ -6843,20 +7369,19 @@
           <a:noFill/>
         </p:spPr>
         <p:txBody>
-          <a:bodyPr wrap="none">
+          <a:bodyPr wrap="square" lIns="27432" rIns="27432" tIns="18288" bIns="18288">
             <a:spAutoFit/>
           </a:bodyPr>
           <a:lstStyle/>
           <a:p>
-            <a:pPr>
-              <a:defRPr sz="1400" b="1">
+            <a:pPr algn="l"/>
+            <a:r>
+              <a:rPr sz="1500" b="1">
                 <a:solidFill>
                   <a:srgbClr val="66F1BE"/>
                 </a:solidFill>
                 <a:latin typeface="Arial"/>
-              </a:defRPr>
-            </a:pPr>
-            <a:r>
+              </a:rPr>
               <a:t>•</a:t>
             </a:r>
           </a:p>
@@ -6870,8 +7395,8 @@
         </p:nvSpPr>
         <p:spPr>
           <a:xfrm>
-            <a:off x="1298448" y="3950208"/>
-            <a:ext cx="5897880" cy="502920"/>
+            <a:off x="1261872" y="3959352"/>
+            <a:ext cx="4800600" cy="438912"/>
           </a:xfrm>
           <a:prstGeom prst="rect">
             <a:avLst/>
@@ -6879,21 +7404,20 @@
           <a:noFill/>
         </p:spPr>
         <p:txBody>
-          <a:bodyPr wrap="none">
+          <a:bodyPr wrap="square" lIns="27432" rIns="27432" tIns="18288" bIns="18288">
             <a:spAutoFit/>
           </a:bodyPr>
           <a:lstStyle/>
           <a:p>
-            <a:pPr>
-              <a:defRPr sz="1400" b="0">
+            <a:pPr algn="l"/>
+            <a:r>
+              <a:rPr sz="1200" b="0">
                 <a:solidFill>
                   <a:srgbClr val="F0F3F8"/>
                 </a:solidFill>
                 <a:latin typeface="Arial"/>
-              </a:defRPr>
-            </a:pPr>
-            <a:r>
-              <a:t>Schema validation catches malformed output</a:t>
+              </a:rPr>
+              <a:t>Şema doğrulaması hatalı çıktıları yakalar</a:t>
             </a:r>
           </a:p>
         </p:txBody>
@@ -6906,8 +7430,8 @@
         </p:nvSpPr>
         <p:spPr>
           <a:xfrm>
-            <a:off x="987552" y="4498848"/>
-            <a:ext cx="274320" cy="320040"/>
+            <a:off x="960120" y="4498848"/>
+            <a:ext cx="228600" cy="274320"/>
           </a:xfrm>
           <a:prstGeom prst="rect">
             <a:avLst/>
@@ -6915,20 +7439,19 @@
           <a:noFill/>
         </p:spPr>
         <p:txBody>
-          <a:bodyPr wrap="none">
+          <a:bodyPr wrap="square" lIns="27432" rIns="27432" tIns="18288" bIns="18288">
             <a:spAutoFit/>
           </a:bodyPr>
           <a:lstStyle/>
           <a:p>
-            <a:pPr>
-              <a:defRPr sz="1400" b="1">
+            <a:pPr algn="l"/>
+            <a:r>
+              <a:rPr sz="1500" b="1">
                 <a:solidFill>
                   <a:srgbClr val="66F1BE"/>
                 </a:solidFill>
                 <a:latin typeface="Arial"/>
-              </a:defRPr>
-            </a:pPr>
-            <a:r>
+              </a:rPr>
               <a:t>•</a:t>
             </a:r>
           </a:p>
@@ -6942,8 +7465,8 @@
         </p:nvSpPr>
         <p:spPr>
           <a:xfrm>
-            <a:off x="1298448" y="4480560"/>
-            <a:ext cx="5897880" cy="502920"/>
+            <a:off x="1261872" y="4489704"/>
+            <a:ext cx="4800600" cy="438912"/>
           </a:xfrm>
           <a:prstGeom prst="rect">
             <a:avLst/>
@@ -6951,21 +7474,20 @@
           <a:noFill/>
         </p:spPr>
         <p:txBody>
-          <a:bodyPr wrap="none">
+          <a:bodyPr wrap="square" lIns="27432" rIns="27432" tIns="18288" bIns="18288">
             <a:spAutoFit/>
           </a:bodyPr>
           <a:lstStyle/>
           <a:p>
-            <a:pPr>
-              <a:defRPr sz="1400" b="0">
+            <a:pPr algn="l"/>
+            <a:r>
+              <a:rPr sz="1200" b="0">
                 <a:solidFill>
                   <a:srgbClr val="F0F3F8"/>
                 </a:solidFill>
                 <a:latin typeface="Arial"/>
-              </a:defRPr>
-            </a:pPr>
-            <a:r>
-              <a:t>The same renderer produces the final deck</a:t>
+              </a:rPr>
+              <a:t>Aynı PPTX motoru nihai PowerPoint dosyasını üretir</a:t>
             </a:r>
           </a:p>
         </p:txBody>
@@ -6978,8 +7500,8 @@
         </p:nvSpPr>
         <p:spPr>
           <a:xfrm>
-            <a:off x="7955279" y="2606040"/>
-            <a:ext cx="3520440" cy="3246120"/>
+            <a:off x="6766560" y="2606040"/>
+            <a:ext cx="4709160" cy="3246120"/>
           </a:xfrm>
           <a:prstGeom prst="roundRect">
             <a:avLst/>
@@ -7023,8 +7545,8 @@
         </p:nvSpPr>
         <p:spPr>
           <a:xfrm>
-            <a:off x="8275320" y="2907792"/>
-            <a:ext cx="2468880" cy="274320"/>
+            <a:off x="7086600" y="2880360"/>
+            <a:ext cx="2286000" cy="228600"/>
           </a:xfrm>
           <a:prstGeom prst="rect">
             <a:avLst/>
@@ -7032,21 +7554,20 @@
           <a:noFill/>
         </p:spPr>
         <p:txBody>
-          <a:bodyPr wrap="none">
+          <a:bodyPr wrap="square" lIns="27432" rIns="27432" tIns="18288" bIns="18288">
             <a:spAutoFit/>
           </a:bodyPr>
           <a:lstStyle/>
           <a:p>
-            <a:pPr>
-              <a:defRPr sz="800" b="1">
+            <a:pPr algn="l"/>
+            <a:r>
+              <a:rPr sz="800" b="1">
                 <a:solidFill>
                   <a:srgbClr val="66F1BE"/>
                 </a:solidFill>
                 <a:latin typeface="Arial"/>
-              </a:defRPr>
-            </a:pPr>
-            <a:r>
-              <a:t>VISUAL DIRECTION</a:t>
+              </a:rPr>
+              <a:t>YAPILANDIRILMIŞ JSON</a:t>
             </a:r>
           </a:p>
         </p:txBody>
@@ -7059,8 +7580,8 @@
         </p:nvSpPr>
         <p:spPr>
           <a:xfrm>
-            <a:off x="8275320" y="3383280"/>
-            <a:ext cx="2697480" cy="1508760"/>
+            <a:off x="7178040" y="3337560"/>
+            <a:ext cx="3794760" cy="2057400"/>
           </a:xfrm>
           <a:prstGeom prst="rect">
             <a:avLst/>
@@ -7068,21 +7589,100 @@
           <a:noFill/>
         </p:spPr>
         <p:txBody>
-          <a:bodyPr wrap="none">
+          <a:bodyPr wrap="square" lIns="27432" rIns="27432" tIns="18288" bIns="18288">
             <a:spAutoFit/>
           </a:bodyPr>
           <a:lstStyle/>
           <a:p>
-            <a:pPr>
-              <a:defRPr sz="1400" b="0">
+            <a:pPr algn="l"/>
+            <a:r>
+              <a:rPr sz="1200" b="0">
                 <a:solidFill>
                   <a:srgbClr val="F0F3F8"/>
                 </a:solidFill>
                 <a:latin typeface="Arial"/>
-              </a:defRPr>
-            </a:pPr>
-            <a:r>
-              <a:t>Ollama → JSON validator → PPTX renderer</a:t>
+              </a:rPr>
+              <a:t>{</a:t>
+            </a:r>
+            <a:br/>
+            <a:r>
+              <a:rPr sz="1200" b="0">
+                <a:solidFill>
+                  <a:srgbClr val="F0F3F8"/>
+                </a:solidFill>
+                <a:latin typeface="Arial"/>
+              </a:rPr>
+              <a:t>  "title": "...",</a:t>
+            </a:r>
+            <a:br/>
+            <a:r>
+              <a:rPr sz="1200" b="0">
+                <a:solidFill>
+                  <a:srgbClr val="F0F3F8"/>
+                </a:solidFill>
+                <a:latin typeface="Arial"/>
+              </a:rPr>
+              <a:t>  "slides": [</a:t>
+            </a:r>
+            <a:br/>
+            <a:r>
+              <a:rPr sz="1200" b="0">
+                <a:solidFill>
+                  <a:srgbClr val="F0F3F8"/>
+                </a:solidFill>
+                <a:latin typeface="Arial"/>
+              </a:rPr>
+              <a:t>    {</a:t>
+            </a:r>
+            <a:br/>
+            <a:r>
+              <a:rPr sz="1200" b="0">
+                <a:solidFill>
+                  <a:srgbClr val="F0F3F8"/>
+                </a:solidFill>
+                <a:latin typeface="Arial"/>
+              </a:rPr>
+              <a:t>      "title": "...",</a:t>
+            </a:r>
+            <a:br/>
+            <a:r>
+              <a:rPr sz="1200" b="0">
+                <a:solidFill>
+                  <a:srgbClr val="F0F3F8"/>
+                </a:solidFill>
+                <a:latin typeface="Arial"/>
+              </a:rPr>
+              <a:t>      "content": [...]</a:t>
+            </a:r>
+            <a:br/>
+            <a:r>
+              <a:rPr sz="1200" b="0">
+                <a:solidFill>
+                  <a:srgbClr val="F0F3F8"/>
+                </a:solidFill>
+                <a:latin typeface="Arial"/>
+              </a:rPr>
+              <a:t>    }</a:t>
+            </a:r>
+            <a:br/>
+            <a:r>
+              <a:rPr sz="1200" b="0">
+                <a:solidFill>
+                  <a:srgbClr val="F0F3F8"/>
+                </a:solidFill>
+                <a:latin typeface="Arial"/>
+              </a:rPr>
+              <a:t>  ]</a:t>
+            </a:r>
+            <a:br/>
+            <a:r>
+              <a:rPr sz="1200" b="0">
+                <a:solidFill>
+                  <a:srgbClr val="F0F3F8"/>
+                </a:solidFill>
+                <a:latin typeface="Arial"/>
+              </a:rPr>
+              <a:t>}</a:t>
             </a:r>
           </a:p>
         </p:txBody>
@@ -7096,7 +7696,7 @@
         <p:spPr>
           <a:xfrm>
             <a:off x="11155680" y="6446520"/>
-            <a:ext cx="548640" cy="228600"/>
+            <a:ext cx="502920" cy="182880"/>
           </a:xfrm>
           <a:prstGeom prst="rect">
             <a:avLst/>
@@ -7104,20 +7704,19 @@
           <a:noFill/>
         </p:spPr>
         <p:txBody>
-          <a:bodyPr wrap="none">
+          <a:bodyPr wrap="square" lIns="27432" rIns="27432" tIns="18288" bIns="18288">
             <a:spAutoFit/>
           </a:bodyPr>
           <a:lstStyle/>
           <a:p>
-            <a:pPr>
-              <a:defRPr sz="800" b="0">
+            <a:pPr algn="l"/>
+            <a:r>
+              <a:rPr sz="800" b="0">
                 <a:solidFill>
                   <a:srgbClr val="A3ABB8"/>
                 </a:solidFill>
                 <a:latin typeface="Arial"/>
-              </a:defRPr>
-            </a:pPr>
-            <a:r>
+              </a:rPr>
               <a:t>05</a:t>
             </a:r>
           </a:p>
@@ -7166,21 +7765,20 @@
           <a:noFill/>
         </p:spPr>
         <p:txBody>
-          <a:bodyPr wrap="none">
+          <a:bodyPr wrap="square" lIns="27432" rIns="27432" tIns="18288" bIns="18288">
             <a:spAutoFit/>
           </a:bodyPr>
           <a:lstStyle/>
           <a:p>
-            <a:pPr>
-              <a:defRPr sz="800" b="1">
+            <a:pPr algn="l"/>
+            <a:r>
+              <a:rPr sz="800" b="1">
                 <a:solidFill>
                   <a:srgbClr val="66F1BE"/>
                 </a:solidFill>
                 <a:latin typeface="Arial"/>
-              </a:defRPr>
-            </a:pPr>
-            <a:r>
-              <a:t>SLIDE 06</a:t>
+              </a:rPr>
+              <a:t>SLAYT 06</a:t>
             </a:r>
           </a:p>
         </p:txBody>
@@ -7194,7 +7792,7 @@
         <p:spPr>
           <a:xfrm>
             <a:off x="685800" y="914400"/>
-            <a:ext cx="10607040" cy="822960"/>
+            <a:ext cx="10607040" cy="640080"/>
           </a:xfrm>
           <a:prstGeom prst="rect">
             <a:avLst/>
@@ -7202,21 +7800,20 @@
           <a:noFill/>
         </p:spPr>
         <p:txBody>
-          <a:bodyPr wrap="none">
+          <a:bodyPr wrap="square" lIns="27432" rIns="27432" tIns="18288" bIns="18288">
             <a:spAutoFit/>
           </a:bodyPr>
           <a:lstStyle/>
           <a:p>
-            <a:pPr>
-              <a:defRPr sz="2500" b="1">
+            <a:pPr algn="l"/>
+            <a:r>
+              <a:rPr sz="2500" b="1">
                 <a:solidFill>
                   <a:srgbClr val="F0F3F8"/>
                 </a:solidFill>
                 <a:latin typeface="Arial"/>
-              </a:defRPr>
-            </a:pPr>
-            <a:r>
-              <a:t>The next extension is richer document ingestion</a:t>
+              </a:rPr>
+              <a:t>Sonraki geliştirme alanı: daha zengin doküman girdileri</a:t>
             </a:r>
           </a:p>
         </p:txBody>
@@ -7230,7 +7827,7 @@
         <p:spPr>
           <a:xfrm>
             <a:off x="713232" y="1783080"/>
-            <a:ext cx="9875520" cy="594360"/>
+            <a:ext cx="10515600" cy="685800"/>
           </a:xfrm>
           <a:prstGeom prst="rect">
             <a:avLst/>
@@ -7238,21 +7835,20 @@
           <a:noFill/>
         </p:spPr>
         <p:txBody>
-          <a:bodyPr wrap="none">
+          <a:bodyPr wrap="square" lIns="27432" rIns="27432" tIns="18288" bIns="18288">
             <a:spAutoFit/>
           </a:bodyPr>
           <a:lstStyle/>
           <a:p>
-            <a:pPr>
-              <a:defRPr sz="1300" b="0">
+            <a:pPr algn="l"/>
+            <a:r>
+              <a:rPr sz="1300" b="0">
                 <a:solidFill>
                   <a:srgbClr val="A3ABB8"/>
                 </a:solidFill>
                 <a:latin typeface="Arial"/>
-              </a:defRPr>
-            </a:pPr>
-            <a:r>
-              <a:t>The architecture already defines where PDF, DOCX and URL adapters plug into the pipeline.</a:t>
+              </a:rPr>
+              <a:t>Mimari, gelecekte PDF, DOCX ve URL adaptörlerinin iş akışına eklenebileceği şekilde genişletilebilir olarak tasarlanmıştır.</a:t>
             </a:r>
           </a:p>
         </p:txBody>
@@ -7266,7 +7862,7 @@
         <p:spPr>
           <a:xfrm>
             <a:off x="685800" y="2606040"/>
-            <a:ext cx="6995160" cy="3246120"/>
+            <a:ext cx="5806440" cy="3246120"/>
           </a:xfrm>
           <a:prstGeom prst="roundRect">
             <a:avLst/>
@@ -7310,8 +7906,8 @@
         </p:nvSpPr>
         <p:spPr>
           <a:xfrm>
-            <a:off x="987552" y="2907792"/>
-            <a:ext cx="274320" cy="320040"/>
+            <a:off x="960120" y="2907792"/>
+            <a:ext cx="228600" cy="274320"/>
           </a:xfrm>
           <a:prstGeom prst="rect">
             <a:avLst/>
@@ -7319,20 +7915,19 @@
           <a:noFill/>
         </p:spPr>
         <p:txBody>
-          <a:bodyPr wrap="none">
+          <a:bodyPr wrap="square" lIns="27432" rIns="27432" tIns="18288" bIns="18288">
             <a:spAutoFit/>
           </a:bodyPr>
           <a:lstStyle/>
           <a:p>
-            <a:pPr>
-              <a:defRPr sz="1400" b="1">
+            <a:pPr algn="l"/>
+            <a:r>
+              <a:rPr sz="1500" b="1">
                 <a:solidFill>
                   <a:srgbClr val="66F1BE"/>
                 </a:solidFill>
                 <a:latin typeface="Arial"/>
-              </a:defRPr>
-            </a:pPr>
-            <a:r>
+              </a:rPr>
               <a:t>•</a:t>
             </a:r>
           </a:p>
@@ -7346,8 +7941,8 @@
         </p:nvSpPr>
         <p:spPr>
           <a:xfrm>
-            <a:off x="1298448" y="2889504"/>
-            <a:ext cx="5897880" cy="502920"/>
+            <a:off x="1261872" y="2898648"/>
+            <a:ext cx="4800600" cy="438912"/>
           </a:xfrm>
           <a:prstGeom prst="rect">
             <a:avLst/>
@@ -7355,21 +7950,20 @@
           <a:noFill/>
         </p:spPr>
         <p:txBody>
-          <a:bodyPr wrap="none">
+          <a:bodyPr wrap="square" lIns="27432" rIns="27432" tIns="18288" bIns="18288">
             <a:spAutoFit/>
           </a:bodyPr>
           <a:lstStyle/>
           <a:p>
-            <a:pPr>
-              <a:defRPr sz="1400" b="0">
+            <a:pPr algn="l"/>
+            <a:r>
+              <a:rPr sz="1200" b="0">
                 <a:solidFill>
                   <a:srgbClr val="F0F3F8"/>
                 </a:solidFill>
                 <a:latin typeface="Arial"/>
-              </a:defRPr>
-            </a:pPr>
-            <a:r>
-              <a:t>PDF text and table extraction</a:t>
+              </a:rPr>
+              <a:t>Planlanan PDF metin ve tablo çıkarma adaptörü</a:t>
             </a:r>
           </a:p>
         </p:txBody>
@@ -7382,8 +7976,8 @@
         </p:nvSpPr>
         <p:spPr>
           <a:xfrm>
-            <a:off x="987552" y="3438144"/>
-            <a:ext cx="274320" cy="320040"/>
+            <a:off x="960120" y="3438144"/>
+            <a:ext cx="228600" cy="274320"/>
           </a:xfrm>
           <a:prstGeom prst="rect">
             <a:avLst/>
@@ -7391,20 +7985,19 @@
           <a:noFill/>
         </p:spPr>
         <p:txBody>
-          <a:bodyPr wrap="none">
+          <a:bodyPr wrap="square" lIns="27432" rIns="27432" tIns="18288" bIns="18288">
             <a:spAutoFit/>
           </a:bodyPr>
           <a:lstStyle/>
           <a:p>
-            <a:pPr>
-              <a:defRPr sz="1400" b="1">
+            <a:pPr algn="l"/>
+            <a:r>
+              <a:rPr sz="1500" b="1">
                 <a:solidFill>
                   <a:srgbClr val="66F1BE"/>
                 </a:solidFill>
                 <a:latin typeface="Arial"/>
-              </a:defRPr>
-            </a:pPr>
-            <a:r>
+              </a:rPr>
               <a:t>•</a:t>
             </a:r>
           </a:p>
@@ -7418,8 +8011,8 @@
         </p:nvSpPr>
         <p:spPr>
           <a:xfrm>
-            <a:off x="1298448" y="3419856"/>
-            <a:ext cx="5897880" cy="502920"/>
+            <a:off x="1261872" y="3429000"/>
+            <a:ext cx="4800600" cy="438912"/>
           </a:xfrm>
           <a:prstGeom prst="rect">
             <a:avLst/>
@@ -7427,21 +8020,20 @@
           <a:noFill/>
         </p:spPr>
         <p:txBody>
-          <a:bodyPr wrap="none">
+          <a:bodyPr wrap="square" lIns="27432" rIns="27432" tIns="18288" bIns="18288">
             <a:spAutoFit/>
           </a:bodyPr>
           <a:lstStyle/>
           <a:p>
-            <a:pPr>
-              <a:defRPr sz="1400" b="0">
+            <a:pPr algn="l"/>
+            <a:r>
+              <a:rPr sz="1200" b="0">
                 <a:solidFill>
                   <a:srgbClr val="F0F3F8"/>
                 </a:solidFill>
                 <a:latin typeface="Arial"/>
-              </a:defRPr>
-            </a:pPr>
-            <a:r>
-              <a:t>DOCX section-aware parsing</a:t>
+              </a:rPr>
+              <a:t>Planlanan DOCX bölüm bazlı ayrıştırma adaptörü</a:t>
             </a:r>
           </a:p>
         </p:txBody>
@@ -7454,8 +8046,8 @@
         </p:nvSpPr>
         <p:spPr>
           <a:xfrm>
-            <a:off x="987552" y="3968496"/>
-            <a:ext cx="274320" cy="320040"/>
+            <a:off x="960120" y="3968496"/>
+            <a:ext cx="228600" cy="274320"/>
           </a:xfrm>
           <a:prstGeom prst="rect">
             <a:avLst/>
@@ -7463,20 +8055,19 @@
           <a:noFill/>
         </p:spPr>
         <p:txBody>
-          <a:bodyPr wrap="none">
+          <a:bodyPr wrap="square" lIns="27432" rIns="27432" tIns="18288" bIns="18288">
             <a:spAutoFit/>
           </a:bodyPr>
           <a:lstStyle/>
           <a:p>
-            <a:pPr>
-              <a:defRPr sz="1400" b="1">
+            <a:pPr algn="l"/>
+            <a:r>
+              <a:rPr sz="1500" b="1">
                 <a:solidFill>
                   <a:srgbClr val="66F1BE"/>
                 </a:solidFill>
                 <a:latin typeface="Arial"/>
-              </a:defRPr>
-            </a:pPr>
-            <a:r>
+              </a:rPr>
               <a:t>•</a:t>
             </a:r>
           </a:p>
@@ -7490,8 +8081,8 @@
         </p:nvSpPr>
         <p:spPr>
           <a:xfrm>
-            <a:off x="1298448" y="3950208"/>
-            <a:ext cx="5897880" cy="502920"/>
+            <a:off x="1261872" y="3959352"/>
+            <a:ext cx="4800600" cy="438912"/>
           </a:xfrm>
           <a:prstGeom prst="rect">
             <a:avLst/>
@@ -7499,21 +8090,20 @@
           <a:noFill/>
         </p:spPr>
         <p:txBody>
-          <a:bodyPr wrap="none">
+          <a:bodyPr wrap="square" lIns="27432" rIns="27432" tIns="18288" bIns="18288">
             <a:spAutoFit/>
           </a:bodyPr>
           <a:lstStyle/>
           <a:p>
-            <a:pPr>
-              <a:defRPr sz="1400" b="0">
+            <a:pPr algn="l"/>
+            <a:r>
+              <a:rPr sz="1200" b="0">
                 <a:solidFill>
                   <a:srgbClr val="F0F3F8"/>
                 </a:solidFill>
                 <a:latin typeface="Arial"/>
-              </a:defRPr>
-            </a:pPr>
-            <a:r>
-              <a:t>URL content normalization</a:t>
+              </a:rPr>
+              <a:t>Planlanan URL içerik normalizasyonu ve kaynak takibi</a:t>
             </a:r>
           </a:p>
         </p:txBody>
@@ -7526,8 +8116,8 @@
         </p:nvSpPr>
         <p:spPr>
           <a:xfrm>
-            <a:off x="987552" y="4498848"/>
-            <a:ext cx="274320" cy="320040"/>
+            <a:off x="960120" y="4498848"/>
+            <a:ext cx="228600" cy="274320"/>
           </a:xfrm>
           <a:prstGeom prst="rect">
             <a:avLst/>
@@ -7535,20 +8125,19 @@
           <a:noFill/>
         </p:spPr>
         <p:txBody>
-          <a:bodyPr wrap="none">
+          <a:bodyPr wrap="square" lIns="27432" rIns="27432" tIns="18288" bIns="18288">
             <a:spAutoFit/>
           </a:bodyPr>
           <a:lstStyle/>
           <a:p>
-            <a:pPr>
-              <a:defRPr sz="1400" b="1">
+            <a:pPr algn="l"/>
+            <a:r>
+              <a:rPr sz="1500" b="1">
                 <a:solidFill>
                   <a:srgbClr val="66F1BE"/>
                 </a:solidFill>
                 <a:latin typeface="Arial"/>
-              </a:defRPr>
-            </a:pPr>
-            <a:r>
+              </a:rPr>
               <a:t>•</a:t>
             </a:r>
           </a:p>
@@ -7562,8 +8151,8 @@
         </p:nvSpPr>
         <p:spPr>
           <a:xfrm>
-            <a:off x="1298448" y="4480560"/>
-            <a:ext cx="5897880" cy="502920"/>
+            <a:off x="1261872" y="4489704"/>
+            <a:ext cx="4800600" cy="438912"/>
           </a:xfrm>
           <a:prstGeom prst="rect">
             <a:avLst/>
@@ -7571,21 +8160,20 @@
           <a:noFill/>
         </p:spPr>
         <p:txBody>
-          <a:bodyPr wrap="none">
+          <a:bodyPr wrap="square" lIns="27432" rIns="27432" tIns="18288" bIns="18288">
             <a:spAutoFit/>
           </a:bodyPr>
           <a:lstStyle/>
           <a:p>
-            <a:pPr>
-              <a:defRPr sz="1400" b="0">
+            <a:pPr algn="l"/>
+            <a:r>
+              <a:rPr sz="1200" b="0">
                 <a:solidFill>
                   <a:srgbClr val="F0F3F8"/>
                 </a:solidFill>
                 <a:latin typeface="Arial"/>
-              </a:defRPr>
-            </a:pPr>
-            <a:r>
-              <a:t>Source-level citation tracking</a:t>
+              </a:rPr>
+              <a:t>Planlanan kaynak düzeyinde atıf takibi</a:t>
             </a:r>
           </a:p>
         </p:txBody>
@@ -7598,8 +8186,8 @@
         </p:nvSpPr>
         <p:spPr>
           <a:xfrm>
-            <a:off x="7955279" y="2606040"/>
-            <a:ext cx="3520440" cy="3246120"/>
+            <a:off x="6766560" y="2606040"/>
+            <a:ext cx="4709160" cy="3246120"/>
           </a:xfrm>
           <a:prstGeom prst="roundRect">
             <a:avLst/>
@@ -7643,8 +8231,8 @@
         </p:nvSpPr>
         <p:spPr>
           <a:xfrm>
-            <a:off x="8275320" y="2907792"/>
-            <a:ext cx="2468880" cy="274320"/>
+            <a:off x="7086600" y="2880360"/>
+            <a:ext cx="2834640" cy="228600"/>
           </a:xfrm>
           <a:prstGeom prst="rect">
             <a:avLst/>
@@ -7652,35 +8240,365 @@
           <a:noFill/>
         </p:spPr>
         <p:txBody>
-          <a:bodyPr wrap="none">
+          <a:bodyPr wrap="square" lIns="27432" rIns="27432" tIns="18288" bIns="18288">
             <a:spAutoFit/>
           </a:bodyPr>
           <a:lstStyle/>
           <a:p>
-            <a:pPr>
-              <a:defRPr sz="800" b="1">
+            <a:pPr algn="l"/>
+            <a:r>
+              <a:rPr sz="800" b="1">
                 <a:solidFill>
                   <a:srgbClr val="66F1BE"/>
                 </a:solidFill>
                 <a:latin typeface="Arial"/>
-              </a:defRPr>
-            </a:pPr>
-            <a:r>
-              <a:t>VISUAL DIRECTION</a:t>
-            </a:r>
-          </a:p>
-        </p:txBody>
-      </p:sp>
-      <p:sp>
-        <p:nvSpPr>
-          <p:cNvPr id="16" name="TextBox 15"/>
+              </a:rPr>
+              <a:t>PLANLANAN GİRDİ ADAPTÖRLERİ</a:t>
+            </a:r>
+          </a:p>
+        </p:txBody>
+      </p:sp>
+      <p:sp>
+        <p:nvSpPr>
+          <p:cNvPr id="16" name="Rounded Rectangle 15"/>
+          <p:cNvSpPr/>
+          <p:nvPr/>
+        </p:nvSpPr>
+        <p:spPr>
+          <a:xfrm>
+            <a:off x="7132320" y="3429000"/>
+            <a:ext cx="1005840" cy="640080"/>
+          </a:xfrm>
+          <a:prstGeom prst="roundRect">
+            <a:avLst/>
+          </a:prstGeom>
+          <a:solidFill>
+            <a:srgbClr val="161D28"/>
+          </a:solidFill>
+          <a:ln>
+            <a:solidFill>
+              <a:srgbClr val="262D39"/>
+            </a:solidFill>
+          </a:ln>
+        </p:spPr>
+        <p:style>
+          <a:lnRef idx="1">
+            <a:schemeClr val="accent1"/>
+          </a:lnRef>
+          <a:fillRef idx="3">
+            <a:schemeClr val="accent1"/>
+          </a:fillRef>
+          <a:effectRef idx="2">
+            <a:schemeClr val="accent1"/>
+          </a:effectRef>
+          <a:fontRef idx="minor">
+            <a:schemeClr val="lt1"/>
+          </a:fontRef>
+        </p:style>
+        <p:txBody>
+          <a:bodyPr rtlCol="0" anchor="ctr"/>
+          <a:lstStyle/>
+          <a:p>
+            <a:pPr algn="ctr"/>
+            <a:r>
+              <a:rPr sz="1100" b="1">
+                <a:solidFill>
+                  <a:srgbClr val="F0F3F8"/>
+                </a:solidFill>
+                <a:latin typeface="Arial"/>
+              </a:rPr>
+              <a:t>PDF</a:t>
+            </a:r>
+          </a:p>
+        </p:txBody>
+      </p:sp>
+      <p:sp>
+        <p:nvSpPr>
+          <p:cNvPr id="17" name="Rounded Rectangle 16"/>
+          <p:cNvSpPr/>
+          <p:nvPr/>
+        </p:nvSpPr>
+        <p:spPr>
+          <a:xfrm>
+            <a:off x="7132320" y="4251960"/>
+            <a:ext cx="1005840" cy="640080"/>
+          </a:xfrm>
+          <a:prstGeom prst="roundRect">
+            <a:avLst/>
+          </a:prstGeom>
+          <a:solidFill>
+            <a:srgbClr val="161D28"/>
+          </a:solidFill>
+          <a:ln>
+            <a:solidFill>
+              <a:srgbClr val="262D39"/>
+            </a:solidFill>
+          </a:ln>
+        </p:spPr>
+        <p:style>
+          <a:lnRef idx="1">
+            <a:schemeClr val="accent1"/>
+          </a:lnRef>
+          <a:fillRef idx="3">
+            <a:schemeClr val="accent1"/>
+          </a:fillRef>
+          <a:effectRef idx="2">
+            <a:schemeClr val="accent1"/>
+          </a:effectRef>
+          <a:fontRef idx="minor">
+            <a:schemeClr val="lt1"/>
+          </a:fontRef>
+        </p:style>
+        <p:txBody>
+          <a:bodyPr rtlCol="0" anchor="ctr"/>
+          <a:lstStyle/>
+          <a:p>
+            <a:pPr algn="ctr"/>
+            <a:r>
+              <a:rPr sz="1100" b="1">
+                <a:solidFill>
+                  <a:srgbClr val="F0F3F8"/>
+                </a:solidFill>
+                <a:latin typeface="Arial"/>
+              </a:rPr>
+              <a:t>DOCX</a:t>
+            </a:r>
+          </a:p>
+        </p:txBody>
+      </p:sp>
+      <p:sp>
+        <p:nvSpPr>
+          <p:cNvPr id="18" name="Rounded Rectangle 17"/>
+          <p:cNvSpPr/>
+          <p:nvPr/>
+        </p:nvSpPr>
+        <p:spPr>
+          <a:xfrm>
+            <a:off x="7132320" y="5074920"/>
+            <a:ext cx="1005840" cy="640080"/>
+          </a:xfrm>
+          <a:prstGeom prst="roundRect">
+            <a:avLst/>
+          </a:prstGeom>
+          <a:solidFill>
+            <a:srgbClr val="161D28"/>
+          </a:solidFill>
+          <a:ln>
+            <a:solidFill>
+              <a:srgbClr val="262D39"/>
+            </a:solidFill>
+          </a:ln>
+        </p:spPr>
+        <p:style>
+          <a:lnRef idx="1">
+            <a:schemeClr val="accent1"/>
+          </a:lnRef>
+          <a:fillRef idx="3">
+            <a:schemeClr val="accent1"/>
+          </a:fillRef>
+          <a:effectRef idx="2">
+            <a:schemeClr val="accent1"/>
+          </a:effectRef>
+          <a:fontRef idx="minor">
+            <a:schemeClr val="lt1"/>
+          </a:fontRef>
+        </p:style>
+        <p:txBody>
+          <a:bodyPr rtlCol="0" anchor="ctr"/>
+          <a:lstStyle/>
+          <a:p>
+            <a:pPr algn="ctr"/>
+            <a:r>
+              <a:rPr sz="1100" b="1">
+                <a:solidFill>
+                  <a:srgbClr val="F0F3F8"/>
+                </a:solidFill>
+                <a:latin typeface="Arial"/>
+              </a:rPr>
+              <a:t>URL</a:t>
+            </a:r>
+          </a:p>
+        </p:txBody>
+      </p:sp>
+      <p:sp>
+        <p:nvSpPr>
+          <p:cNvPr id="19" name="Rounded Rectangle 18"/>
+          <p:cNvSpPr/>
+          <p:nvPr/>
+        </p:nvSpPr>
+        <p:spPr>
+          <a:xfrm>
+            <a:off x="9464040" y="4160520"/>
+            <a:ext cx="1600200" cy="822960"/>
+          </a:xfrm>
+          <a:prstGeom prst="roundRect">
+            <a:avLst/>
+          </a:prstGeom>
+          <a:solidFill>
+            <a:srgbClr val="161D28"/>
+          </a:solidFill>
+          <a:ln>
+            <a:solidFill>
+              <a:srgbClr val="262D39"/>
+            </a:solidFill>
+          </a:ln>
+        </p:spPr>
+        <p:style>
+          <a:lnRef idx="1">
+            <a:schemeClr val="accent1"/>
+          </a:lnRef>
+          <a:fillRef idx="3">
+            <a:schemeClr val="accent1"/>
+          </a:fillRef>
+          <a:effectRef idx="2">
+            <a:schemeClr val="accent1"/>
+          </a:effectRef>
+          <a:fontRef idx="minor">
+            <a:schemeClr val="lt1"/>
+          </a:fontRef>
+        </p:style>
+        <p:txBody>
+          <a:bodyPr rtlCol="0" anchor="ctr"/>
+          <a:lstStyle/>
+          <a:p>
+            <a:pPr algn="ctr"/>
+            <a:r>
+              <a:rPr sz="1100" b="1">
+                <a:solidFill>
+                  <a:srgbClr val="F0F3F8"/>
+                </a:solidFill>
+                <a:latin typeface="Arial"/>
+              </a:rPr>
+              <a:t>NORMALİZE EDİLMİŞ</a:t>
+            </a:r>
+            <a:br/>
+            <a:r>
+              <a:rPr sz="1100" b="1">
+                <a:solidFill>
+                  <a:srgbClr val="F0F3F8"/>
+                </a:solidFill>
+                <a:latin typeface="Arial"/>
+              </a:rPr>
+              <a:t>KANIT</a:t>
+            </a:r>
+          </a:p>
+        </p:txBody>
+      </p:sp>
+      <p:cxnSp>
+        <p:nvCxnSpPr>
+          <p:cNvPr id="20" name="Connector 19"/>
+          <p:cNvCxnSpPr/>
+          <p:nvPr/>
+        </p:nvCxnSpPr>
+        <p:spPr>
+          <a:xfrm>
+            <a:off x="8138160" y="3749039"/>
+            <a:ext cx="1325880" cy="640081"/>
+          </a:xfrm>
+          <a:prstGeom prst="line">
+            <a:avLst/>
+          </a:prstGeom>
+          <a:ln w="25400">
+            <a:solidFill>
+              <a:srgbClr val="66F1BE"/>
+            </a:solidFill>
+          </a:ln>
+        </p:spPr>
+        <p:style>
+          <a:lnRef idx="2">
+            <a:schemeClr val="accent1"/>
+          </a:lnRef>
+          <a:fillRef idx="0">
+            <a:schemeClr val="accent1"/>
+          </a:fillRef>
+          <a:effectRef idx="1">
+            <a:schemeClr val="accent1"/>
+          </a:effectRef>
+          <a:fontRef idx="minor">
+            <a:schemeClr val="tx1"/>
+          </a:fontRef>
+        </p:style>
+      </p:cxnSp>
+      <p:cxnSp>
+        <p:nvCxnSpPr>
+          <p:cNvPr id="21" name="Connector 20"/>
+          <p:cNvCxnSpPr/>
+          <p:nvPr/>
+        </p:nvCxnSpPr>
+        <p:spPr>
+          <a:xfrm>
+            <a:off x="8138160" y="4572000"/>
+            <a:ext cx="1325880" cy="0"/>
+          </a:xfrm>
+          <a:prstGeom prst="line">
+            <a:avLst/>
+          </a:prstGeom>
+          <a:ln w="25400">
+            <a:solidFill>
+              <a:srgbClr val="66F1BE"/>
+            </a:solidFill>
+          </a:ln>
+        </p:spPr>
+        <p:style>
+          <a:lnRef idx="2">
+            <a:schemeClr val="accent1"/>
+          </a:lnRef>
+          <a:fillRef idx="0">
+            <a:schemeClr val="accent1"/>
+          </a:fillRef>
+          <a:effectRef idx="1">
+            <a:schemeClr val="accent1"/>
+          </a:effectRef>
+          <a:fontRef idx="minor">
+            <a:schemeClr val="tx1"/>
+          </a:fontRef>
+        </p:style>
+      </p:cxnSp>
+      <p:cxnSp>
+        <p:nvCxnSpPr>
+          <p:cNvPr id="22" name="Connector 21"/>
+          <p:cNvCxnSpPr/>
+          <p:nvPr/>
+        </p:nvCxnSpPr>
+        <p:spPr>
+          <a:xfrm flipV="1">
+            <a:off x="8138160" y="4754880"/>
+            <a:ext cx="1325880" cy="640080"/>
+          </a:xfrm>
+          <a:prstGeom prst="line">
+            <a:avLst/>
+          </a:prstGeom>
+          <a:ln w="25400">
+            <a:solidFill>
+              <a:srgbClr val="66F1BE"/>
+            </a:solidFill>
+          </a:ln>
+        </p:spPr>
+        <p:style>
+          <a:lnRef idx="2">
+            <a:schemeClr val="accent1"/>
+          </a:lnRef>
+          <a:fillRef idx="0">
+            <a:schemeClr val="accent1"/>
+          </a:fillRef>
+          <a:effectRef idx="1">
+            <a:schemeClr val="accent1"/>
+          </a:effectRef>
+          <a:fontRef idx="minor">
+            <a:schemeClr val="tx1"/>
+          </a:fontRef>
+        </p:style>
+      </p:cxnSp>
+      <p:sp>
+        <p:nvSpPr>
+          <p:cNvPr id="23" name="TextBox 22"/>
           <p:cNvSpPr txBox="1"/>
           <p:nvPr/>
         </p:nvSpPr>
         <p:spPr>
           <a:xfrm>
-            <a:off x="8275320" y="3383280"/>
-            <a:ext cx="2697480" cy="1508760"/>
+            <a:off x="11155680" y="6446520"/>
+            <a:ext cx="502920" cy="182880"/>
           </a:xfrm>
           <a:prstGeom prst="rect">
             <a:avLst/>
@@ -7688,56 +8606,19 @@
           <a:noFill/>
         </p:spPr>
         <p:txBody>
-          <a:bodyPr wrap="none">
+          <a:bodyPr wrap="square" lIns="27432" rIns="27432" tIns="18288" bIns="18288">
             <a:spAutoFit/>
           </a:bodyPr>
           <a:lstStyle/>
           <a:p>
-            <a:pPr>
-              <a:defRPr sz="1400" b="0">
-                <a:solidFill>
-                  <a:srgbClr val="F0F3F8"/>
-                </a:solidFill>
-                <a:latin typeface="Arial"/>
-              </a:defRPr>
-            </a:pPr>
-            <a:r>
-              <a:t>Three input adapters converging into one normalized evidence object</a:t>
-            </a:r>
-          </a:p>
-        </p:txBody>
-      </p:sp>
-      <p:sp>
-        <p:nvSpPr>
-          <p:cNvPr id="17" name="TextBox 16"/>
-          <p:cNvSpPr txBox="1"/>
-          <p:nvPr/>
-        </p:nvSpPr>
-        <p:spPr>
-          <a:xfrm>
-            <a:off x="11155680" y="6446520"/>
-            <a:ext cx="548640" cy="228600"/>
-          </a:xfrm>
-          <a:prstGeom prst="rect">
-            <a:avLst/>
-          </a:prstGeom>
-          <a:noFill/>
-        </p:spPr>
-        <p:txBody>
-          <a:bodyPr wrap="none">
-            <a:spAutoFit/>
-          </a:bodyPr>
-          <a:lstStyle/>
-          <a:p>
-            <a:pPr>
-              <a:defRPr sz="800" b="0">
+            <a:pPr algn="l"/>
+            <a:r>
+              <a:rPr sz="800" b="0">
                 <a:solidFill>
                   <a:srgbClr val="A3ABB8"/>
                 </a:solidFill>
                 <a:latin typeface="Arial"/>
-              </a:defRPr>
-            </a:pPr>
-            <a:r>
+              </a:rPr>
               <a:t>06</a:t>
             </a:r>
           </a:p>

</xml_diff>